<commit_message>
[docs] report 2026-09-24 regenerated with W3c (20 slides + PDF), validity across all four registrations
report.py now finds LibreOffice as a Flatpak and exports the PDF; the failing-cell
count on the validity slide is computed, not typed.

Co-Authored-By: Claude Opus 5.5 <noreply@anthropic.com>
</commit_message>
<xml_diff>
--- a/report/2026-09-24/adaptive_therapy_report.pptx
+++ b/report/2026-09-24/adaptive_therapy_report.pptx
@@ -23,6 +23,8 @@
     <p:sldId id="271" r:id="rId23"/>
     <p:sldId id="272" r:id="rId24"/>
     <p:sldId id="273" r:id="rId25"/>
+    <p:sldId id="274" r:id="rId26"/>
+    <p:sldId id="275" r:id="rId27"/>
   </p:sldIdLst>
   <p:sldSz cx="12191695" cy="6858000" type="screen4x3"/>
   <p:notesSz cx="6858000" cy="9144000"/>
@@ -551,6 +553,7 @@
         <c:axId val="-2113994440"/>
         <c:scaling>
           <c:max val="360.0"/>
+          <c:min val="0.0"/>
         </c:scaling>
         <c:delete val="0"/>
         <c:axPos val="l"/>
@@ -563,6 +566,464 @@
             </a:ln>
           </c:spPr>
         </c:majorGridlines>
+        <c:majorTickMark val="out"/>
+        <c:minorTickMark val="none"/>
+        <c:tickLblPos val="nextTo"/>
+        <c:txPr>
+          <a:bodyPr/>
+          <a:lstStyle/>
+          <a:p>
+            <a:pPr>
+              <a:defRPr sz="1100"/>
+            </a:pPr>
+          </a:p>
+        </c:txPr>
+        <c:crossAx val="-2068027336"/>
+        <c:crosses val="autoZero"/>
+      </c:valAx>
+    </c:plotArea>
+    <c:legend>
+      <c:legendPos val="t"/>
+      <c:overlay val="0"/>
+      <c:txPr>
+        <a:bodyPr/>
+        <a:lstStyle/>
+        <a:p>
+          <a:pPr>
+            <a:defRPr sz="1100"/>
+          </a:pPr>
+        </a:p>
+      </c:txPr>
+    </c:legend>
+    <c:dispBlanksAs val="gap"/>
+  </c:chart>
+  <c:txPr>
+    <a:bodyPr/>
+    <a:lstStyle/>
+    <a:p>
+      <a:pPr>
+        <a:defRPr sz="1800"/>
+      </a:pPr>
+      <a:endParaRPr lang="en-US"/>
+    </a:p>
+  </c:txPr>
+  <c:externalData r:id="rId1">
+    <c:autoUpdate val="0"/>
+  </c:externalData>
+</c:chartSpace>
+</file>
+
+<file path=ppt/charts/chart2.xml><?xml version="1.0" encoding="utf-8"?>
+<c:chartSpace xmlns:c="http://schemas.openxmlformats.org/drawingml/2006/chart" xmlns:a="http://schemas.openxmlformats.org/drawingml/2006/main" xmlns:r="http://schemas.openxmlformats.org/officeDocument/2006/relationships">
+  <c:date1904 val="0"/>
+  <c:chart>
+    <c:autoTitleDeleted val="0"/>
+    <c:plotArea>
+      <c:barChart>
+        <c:barDir val="col"/>
+        <c:grouping val="clustered"/>
+        <c:ser>
+          <c:idx val="0"/>
+          <c:order val="0"/>
+          <c:tx>
+            <c:strRef>
+              <c:f>Sheet1!$B$1</c:f>
+              <c:strCache>
+                <c:ptCount val="1"/>
+                <c:pt idx="0">
+                  <c:v>MLP</c:v>
+                </c:pt>
+              </c:strCache>
+            </c:strRef>
+          </c:tx>
+          <c:spPr>
+            <a:solidFill>
+              <a:srgbClr val="1F3B4D"/>
+            </a:solidFill>
+          </c:spPr>
+          <c:cat>
+            <c:strRef>
+              <c:f>Sheet1!$A$2:$A$3</c:f>
+              <c:strCache>
+                <c:ptCount val="2"/>
+                <c:pt idx="0">
+                  <c:v>Tier 0 (no shift)</c:v>
+                </c:pt>
+                <c:pt idx="1">
+                  <c:v>Tier 1 (shifted)</c:v>
+                </c:pt>
+              </c:strCache>
+            </c:strRef>
+          </c:cat>
+          <c:val>
+            <c:numRef>
+              <c:f>Sheet1!$B$2:$B$3</c:f>
+              <c:numCache>
+                <c:formatCode>General</c:formatCode>
+                <c:ptCount val="2"/>
+                <c:pt idx="0">
+                  <c:v>281.6</c:v>
+                </c:pt>
+                <c:pt idx="1">
+                  <c:v>246.8</c:v>
+                </c:pt>
+              </c:numCache>
+            </c:numRef>
+          </c:val>
+        </c:ser>
+        <c:ser>
+          <c:idx val="1"/>
+          <c:order val="1"/>
+          <c:tx>
+            <c:strRef>
+              <c:f>Sheet1!$C$1</c:f>
+              <c:strCache>
+                <c:ptCount val="1"/>
+                <c:pt idx="0">
+                  <c:v>thr0.8</c:v>
+                </c:pt>
+              </c:strCache>
+            </c:strRef>
+          </c:tx>
+          <c:spPr>
+            <a:solidFill>
+              <a:srgbClr val="3C6E71"/>
+            </a:solidFill>
+          </c:spPr>
+          <c:cat>
+            <c:strRef>
+              <c:f>Sheet1!$A$2:$A$3</c:f>
+              <c:strCache>
+                <c:ptCount val="2"/>
+                <c:pt idx="0">
+                  <c:v>Tier 0 (no shift)</c:v>
+                </c:pt>
+                <c:pt idx="1">
+                  <c:v>Tier 1 (shifted)</c:v>
+                </c:pt>
+              </c:strCache>
+            </c:strRef>
+          </c:cat>
+          <c:val>
+            <c:numRef>
+              <c:f>Sheet1!$C$2:$C$3</c:f>
+              <c:numCache>
+                <c:formatCode>General</c:formatCode>
+                <c:ptCount val="2"/>
+                <c:pt idx="0">
+                  <c:v>279.8</c:v>
+                </c:pt>
+                <c:pt idx="1">
+                  <c:v>245.9</c:v>
+                </c:pt>
+              </c:numCache>
+            </c:numRef>
+          </c:val>
+        </c:ser>
+        <c:ser>
+          <c:idx val="2"/>
+          <c:order val="2"/>
+          <c:tx>
+            <c:strRef>
+              <c:f>Sheet1!$D$1</c:f>
+              <c:strCache>
+                <c:ptCount val="1"/>
+                <c:pt idx="0">
+                  <c:v>MTD</c:v>
+                </c:pt>
+              </c:strCache>
+            </c:strRef>
+          </c:tx>
+          <c:spPr>
+            <a:solidFill>
+              <a:srgbClr val="D1495B"/>
+            </a:solidFill>
+          </c:spPr>
+          <c:cat>
+            <c:strRef>
+              <c:f>Sheet1!$A$2:$A$3</c:f>
+              <c:strCache>
+                <c:ptCount val="2"/>
+                <c:pt idx="0">
+                  <c:v>Tier 0 (no shift)</c:v>
+                </c:pt>
+                <c:pt idx="1">
+                  <c:v>Tier 1 (shifted)</c:v>
+                </c:pt>
+              </c:strCache>
+            </c:strRef>
+          </c:cat>
+          <c:val>
+            <c:numRef>
+              <c:f>Sheet1!$D$2:$D$3</c:f>
+              <c:numCache>
+                <c:formatCode>General</c:formatCode>
+                <c:ptCount val="2"/>
+                <c:pt idx="0">
+                  <c:v>258.8</c:v>
+                </c:pt>
+                <c:pt idx="1">
+                  <c:v>223.9</c:v>
+                </c:pt>
+              </c:numCache>
+            </c:numRef>
+          </c:val>
+        </c:ser>
+        <c:ser>
+          <c:idx val="3"/>
+          <c:order val="3"/>
+          <c:tx>
+            <c:strRef>
+              <c:f>Sheet1!$E$1</c:f>
+              <c:strCache>
+                <c:ptCount val="1"/>
+                <c:pt idx="0">
+                  <c:v>LSTM</c:v>
+                </c:pt>
+              </c:strCache>
+            </c:strRef>
+          </c:tx>
+          <c:spPr>
+            <a:solidFill>
+              <a:srgbClr val="8E7DBE"/>
+            </a:solidFill>
+          </c:spPr>
+          <c:cat>
+            <c:strRef>
+              <c:f>Sheet1!$A$2:$A$3</c:f>
+              <c:strCache>
+                <c:ptCount val="2"/>
+                <c:pt idx="0">
+                  <c:v>Tier 0 (no shift)</c:v>
+                </c:pt>
+                <c:pt idx="1">
+                  <c:v>Tier 1 (shifted)</c:v>
+                </c:pt>
+              </c:strCache>
+            </c:strRef>
+          </c:cat>
+          <c:val>
+            <c:numRef>
+              <c:f>Sheet1!$E$2:$E$3</c:f>
+              <c:numCache>
+                <c:formatCode>General</c:formatCode>
+                <c:ptCount val="2"/>
+                <c:pt idx="0">
+                  <c:v>207.9</c:v>
+                </c:pt>
+                <c:pt idx="1">
+                  <c:v>164.0</c:v>
+                </c:pt>
+              </c:numCache>
+            </c:numRef>
+          </c:val>
+        </c:ser>
+        <c:ser>
+          <c:idx val="4"/>
+          <c:order val="4"/>
+          <c:tx>
+            <c:strRef>
+              <c:f>Sheet1!$F$1</c:f>
+              <c:strCache>
+                <c:ptCount val="1"/>
+                <c:pt idx="0">
+                  <c:v>ODE-RNN</c:v>
+                </c:pt>
+              </c:strCache>
+            </c:strRef>
+          </c:tx>
+          <c:spPr>
+            <a:solidFill>
+              <a:srgbClr val="2A9D8F"/>
+            </a:solidFill>
+          </c:spPr>
+          <c:cat>
+            <c:strRef>
+              <c:f>Sheet1!$A$2:$A$3</c:f>
+              <c:strCache>
+                <c:ptCount val="2"/>
+                <c:pt idx="0">
+                  <c:v>Tier 0 (no shift)</c:v>
+                </c:pt>
+                <c:pt idx="1">
+                  <c:v>Tier 1 (shifted)</c:v>
+                </c:pt>
+              </c:strCache>
+            </c:strRef>
+          </c:cat>
+          <c:val>
+            <c:numRef>
+              <c:f>Sheet1!$F$2:$F$3</c:f>
+              <c:numCache>
+                <c:formatCode>General</c:formatCode>
+                <c:ptCount val="2"/>
+                <c:pt idx="0">
+                  <c:v>196.9</c:v>
+                </c:pt>
+                <c:pt idx="1">
+                  <c:v>154.5</c:v>
+                </c:pt>
+              </c:numCache>
+            </c:numRef>
+          </c:val>
+        </c:ser>
+        <c:ser>
+          <c:idx val="5"/>
+          <c:order val="5"/>
+          <c:tx>
+            <c:strRef>
+              <c:f>Sheet1!$G$1</c:f>
+              <c:strCache>
+                <c:ptCount val="1"/>
+                <c:pt idx="0">
+                  <c:v>AT50</c:v>
+                </c:pt>
+              </c:strCache>
+            </c:strRef>
+          </c:tx>
+          <c:spPr>
+            <a:solidFill>
+              <a:srgbClr val="E09F3E"/>
+            </a:solidFill>
+          </c:spPr>
+          <c:cat>
+            <c:strRef>
+              <c:f>Sheet1!$A$2:$A$3</c:f>
+              <c:strCache>
+                <c:ptCount val="2"/>
+                <c:pt idx="0">
+                  <c:v>Tier 0 (no shift)</c:v>
+                </c:pt>
+                <c:pt idx="1">
+                  <c:v>Tier 1 (shifted)</c:v>
+                </c:pt>
+              </c:strCache>
+            </c:strRef>
+          </c:cat>
+          <c:val>
+            <c:numRef>
+              <c:f>Sheet1!$G$2:$G$3</c:f>
+              <c:numCache>
+                <c:formatCode>General</c:formatCode>
+                <c:ptCount val="2"/>
+                <c:pt idx="0">
+                  <c:v>152.1</c:v>
+                </c:pt>
+                <c:pt idx="1">
+                  <c:v>124.6</c:v>
+                </c:pt>
+              </c:numCache>
+            </c:numRef>
+          </c:val>
+        </c:ser>
+        <c:ser>
+          <c:idx val="6"/>
+          <c:order val="6"/>
+          <c:tx>
+            <c:strRef>
+              <c:f>Sheet1!$H$1</c:f>
+              <c:strCache>
+                <c:ptCount val="1"/>
+                <c:pt idx="0">
+                  <c:v>none</c:v>
+                </c:pt>
+              </c:strCache>
+            </c:strRef>
+          </c:tx>
+          <c:spPr>
+            <a:solidFill>
+              <a:srgbClr val="9A9A9A"/>
+            </a:solidFill>
+          </c:spPr>
+          <c:cat>
+            <c:strRef>
+              <c:f>Sheet1!$A$2:$A$3</c:f>
+              <c:strCache>
+                <c:ptCount val="2"/>
+                <c:pt idx="0">
+                  <c:v>Tier 0 (no shift)</c:v>
+                </c:pt>
+                <c:pt idx="1">
+                  <c:v>Tier 1 (shifted)</c:v>
+                </c:pt>
+              </c:strCache>
+            </c:strRef>
+          </c:cat>
+          <c:val>
+            <c:numRef>
+              <c:f>Sheet1!$H$2:$H$3</c:f>
+              <c:numCache>
+                <c:formatCode>General</c:formatCode>
+                <c:ptCount val="2"/>
+                <c:pt idx="0">
+                  <c:v>139.8</c:v>
+                </c:pt>
+                <c:pt idx="1">
+                  <c:v>97.9</c:v>
+                </c:pt>
+              </c:numCache>
+            </c:numRef>
+          </c:val>
+        </c:ser>
+        <c:axId val="-2068027336"/>
+        <c:axId val="-2113994440"/>
+      </c:barChart>
+      <c:catAx>
+        <c:axId val="-2068027336"/>
+        <c:scaling>
+          <c:orientation val="minMax"/>
+        </c:scaling>
+        <c:delete val="0"/>
+        <c:axPos val="b"/>
+        <c:majorTickMark val="out"/>
+        <c:minorTickMark val="none"/>
+        <c:tickLblPos val="nextTo"/>
+        <c:txPr>
+          <a:bodyPr/>
+          <a:lstStyle/>
+          <a:p>
+            <a:pPr>
+              <a:defRPr sz="1200"/>
+            </a:pPr>
+          </a:p>
+        </c:txPr>
+        <c:crossAx val="-2113994440"/>
+        <c:crosses val="autoZero"/>
+        <c:auto val="1"/>
+        <c:lblAlgn val="ctr"/>
+        <c:lblOffset val="100"/>
+        <c:noMultiLvlLbl val="0"/>
+      </c:catAx>
+      <c:valAx>
+        <c:axId val="-2113994440"/>
+        <c:scaling/>
+        <c:delete val="0"/>
+        <c:axPos val="l"/>
+        <c:majorGridlines>
+          <c:spPr>
+            <a:ln>
+              <a:solidFill>
+                <a:srgbClr val="DDDDDD"/>
+              </a:solidFill>
+            </a:ln>
+          </c:spPr>
+        </c:majorGridlines>
+        <c:title>
+          <c:tx>
+            <c:rich>
+              <a:bodyPr/>
+              <a:lstStyle/>
+              <a:p>
+                <a:r>
+                  <a:rPr sz="1100"/>
+                  <a:t>mean U over w (days)</a:t>
+                </a:r>
+              </a:p>
+            </c:rich>
+          </c:tx>
+          <c:layout/>
+          <c:overlay val="0"/>
+        </c:title>
         <c:majorTickMark val="out"/>
         <c:minorTickMark val="none"/>
         <c:tickLblPos val="nextTo"/>
@@ -1565,7 +2026,7 @@
           <a:lstStyle/>
           <a:p>
             <a:r>
-              <a:t>ROADMAP traps 4-6 plus the W3 ceiling; each now has an automatic check.</a:t>
+              <a:t>PREREG W3c: per-cell validity, 5 fresh seeds, primary = paired U = min(TTP, 357) - w * exposure, the survival and exposure terms each cell was trained to maximise, averaged over w. Rules are descriptive reference points on the same patients.</a:t>
             </a:r>
           </a:p>
         </p:txBody>
@@ -1635,7 +2096,77 @@
           <a:lstStyle/>
           <a:p>
             <a:r>
-              <a:t>Target: an ICLR 2027 workshop; a clean negative is still the paper.</a:t>
+              <a:t>Per exposure weight. At w = 0.40 both recurrent arms score below never treating on Tier 1; the ODE-RNN beats the LSTM at w 0.10 and 0.40 but loses badly at 0.20.</a:t>
+            </a:r>
+          </a:p>
+        </p:txBody>
+      </p:sp>
+      <p:sp>
+        <p:nvSpPr>
+          <p:cNvPr id="4" name="Slide Number Placeholder 3"/>
+          <p:cNvSpPr>
+            <a:spLocks noGrp="1"/>
+          </p:cNvSpPr>
+          <p:nvPr>
+            <p:ph type="sldNum" idx="5" sz="quarter"/>
+          </p:nvPr>
+        </p:nvSpPr>
+        <p:spPr/>
+      </p:sp>
+    </p:spTree>
+  </p:cSld>
+  <p:clrMapOvr>
+    <a:masterClrMapping/>
+  </p:clrMapOvr>
+</p:notes>
+</file>
+
+<file path=ppt/notesSlides/notesSlide19.xml><?xml version="1.0" encoding="utf-8"?>
+<p:notes xmlns:a="http://schemas.openxmlformats.org/drawingml/2006/main" xmlns:p="http://schemas.openxmlformats.org/presentationml/2006/main" xmlns:r="http://schemas.openxmlformats.org/officeDocument/2006/relationships">
+  <p:cSld>
+    <p:spTree>
+      <p:nvGrpSpPr>
+        <p:cNvPr id="1" name=""/>
+        <p:cNvGrpSpPr/>
+        <p:nvPr/>
+      </p:nvGrpSpPr>
+      <p:grpSpPr>
+        <a:xfrm>
+          <a:off x="0" y="0"/>
+          <a:ext cx="0" cy="0"/>
+          <a:chOff x="0" y="0"/>
+          <a:chExt cx="0" cy="0"/>
+        </a:xfrm>
+      </p:grpSpPr>
+      <p:sp>
+        <p:nvSpPr>
+          <p:cNvPr id="2" name="Slide Image Placeholder 1"/>
+          <p:cNvSpPr>
+            <a:spLocks noGrp="1"/>
+          </p:cNvSpPr>
+          <p:nvPr>
+            <p:ph type="sldImg" idx="2"/>
+          </p:nvPr>
+        </p:nvSpPr>
+        <p:spPr/>
+      </p:sp>
+      <p:sp>
+        <p:nvSpPr>
+          <p:cNvPr id="3" name="Notes Placeholder 2"/>
+          <p:cNvSpPr>
+            <a:spLocks noGrp="1"/>
+          </p:cNvSpPr>
+          <p:nvPr>
+            <p:ph type="body" idx="3" sz="quarter"/>
+          </p:nvPr>
+        </p:nvSpPr>
+        <p:spPr/>
+        <p:txBody>
+          <a:bodyPr/>
+          <a:lstStyle/>
+          <a:p>
+            <a:r>
+              <a:t>ROADMAP traps 4-6 plus the W3 ceiling; each now has an automatic check.</a:t>
             </a:r>
           </a:p>
         </p:txBody>
@@ -1706,6 +2237,76 @@
           <a:p>
             <a:r>
               <a:t>The ablation axis is the policy architecture; everything else in the loop is fixed. The agent only sees total burden, never the sensitive/resistant split, so this is a POMDP.</a:t>
+            </a:r>
+          </a:p>
+        </p:txBody>
+      </p:sp>
+      <p:sp>
+        <p:nvSpPr>
+          <p:cNvPr id="4" name="Slide Number Placeholder 3"/>
+          <p:cNvSpPr>
+            <a:spLocks noGrp="1"/>
+          </p:cNvSpPr>
+          <p:nvPr>
+            <p:ph type="sldNum" idx="5" sz="quarter"/>
+          </p:nvPr>
+        </p:nvSpPr>
+        <p:spPr/>
+      </p:sp>
+    </p:spTree>
+  </p:cSld>
+  <p:clrMapOvr>
+    <a:masterClrMapping/>
+  </p:clrMapOvr>
+</p:notes>
+</file>
+
+<file path=ppt/notesSlides/notesSlide20.xml><?xml version="1.0" encoding="utf-8"?>
+<p:notes xmlns:a="http://schemas.openxmlformats.org/drawingml/2006/main" xmlns:p="http://schemas.openxmlformats.org/presentationml/2006/main" xmlns:r="http://schemas.openxmlformats.org/officeDocument/2006/relationships">
+  <p:cSld>
+    <p:spTree>
+      <p:nvGrpSpPr>
+        <p:cNvPr id="1" name=""/>
+        <p:cNvGrpSpPr/>
+        <p:nvPr/>
+      </p:nvGrpSpPr>
+      <p:grpSpPr>
+        <a:xfrm>
+          <a:off x="0" y="0"/>
+          <a:ext cx="0" cy="0"/>
+          <a:chOff x="0" y="0"/>
+          <a:chExt cx="0" cy="0"/>
+        </a:xfrm>
+      </p:grpSpPr>
+      <p:sp>
+        <p:nvSpPr>
+          <p:cNvPr id="2" name="Slide Image Placeholder 1"/>
+          <p:cNvSpPr>
+            <a:spLocks noGrp="1"/>
+          </p:cNvSpPr>
+          <p:nvPr>
+            <p:ph type="sldImg" idx="2"/>
+          </p:nvPr>
+        </p:nvSpPr>
+        <p:spPr/>
+      </p:sp>
+      <p:sp>
+        <p:nvSpPr>
+          <p:cNvPr id="3" name="Notes Placeholder 2"/>
+          <p:cNvSpPr>
+            <a:spLocks noGrp="1"/>
+          </p:cNvSpPr>
+          <p:nvPr>
+            <p:ph type="body" idx="3" sz="quarter"/>
+          </p:nvPr>
+        </p:nvSpPr>
+        <p:spPr/>
+        <p:txBody>
+          <a:bodyPr/>
+          <a:lstStyle/>
+          <a:p>
+            <a:r>
+              <a:t>Target: an ICLR 2027 workshop; a clean negative is still the paper.</a:t>
             </a:r>
           </a:p>
         </p:txBody>
@@ -5482,7 +6083,7 @@
         </p:nvSpPr>
         <p:spPr>
           <a:xfrm>
-            <a:off x="986008" y="3072384"/>
+            <a:off x="908964" y="3072384"/>
             <a:ext cx="512064" cy="512064"/>
           </a:xfrm>
           <a:prstGeom prst="ellipse">
@@ -5535,8 +6136,8 @@
         </p:nvSpPr>
         <p:spPr>
           <a:xfrm>
-            <a:off x="594360" y="2148840"/>
-            <a:ext cx="1295361" cy="411480"/>
+            <a:off x="594359" y="2148840"/>
+            <a:ext cx="1141272" cy="411480"/>
           </a:xfrm>
           <a:prstGeom prst="rect">
             <a:avLst/>
@@ -5574,8 +6175,8 @@
         </p:nvSpPr>
         <p:spPr>
           <a:xfrm>
-            <a:off x="594360" y="2560320"/>
-            <a:ext cx="1295361" cy="365760"/>
+            <a:off x="594359" y="2560320"/>
+            <a:ext cx="1141272" cy="365760"/>
           </a:xfrm>
           <a:prstGeom prst="rect">
             <a:avLst/>
@@ -5613,8 +6214,8 @@
         </p:nvSpPr>
         <p:spPr>
           <a:xfrm>
-            <a:off x="594360" y="3840480"/>
-            <a:ext cx="1295361" cy="822960"/>
+            <a:off x="594359" y="3840480"/>
+            <a:ext cx="1141272" cy="822960"/>
           </a:xfrm>
           <a:prstGeom prst="rect">
             <a:avLst/>
@@ -5653,7 +6254,7 @@
         </p:nvSpPr>
         <p:spPr>
           <a:xfrm>
-            <a:off x="2372810" y="3072384"/>
+            <a:off x="2141677" y="3072384"/>
             <a:ext cx="512064" cy="512064"/>
           </a:xfrm>
           <a:prstGeom prst="ellipse">
@@ -5706,8 +6307,8 @@
         </p:nvSpPr>
         <p:spPr>
           <a:xfrm>
-            <a:off x="1981161" y="2148840"/>
-            <a:ext cx="1295361" cy="411480"/>
+            <a:off x="1827072" y="2148840"/>
+            <a:ext cx="1141272" cy="411480"/>
           </a:xfrm>
           <a:prstGeom prst="rect">
             <a:avLst/>
@@ -5745,8 +6346,8 @@
         </p:nvSpPr>
         <p:spPr>
           <a:xfrm>
-            <a:off x="1981161" y="2560320"/>
-            <a:ext cx="1295361" cy="365760"/>
+            <a:off x="1827072" y="2560320"/>
+            <a:ext cx="1141272" cy="365760"/>
           </a:xfrm>
           <a:prstGeom prst="rect">
             <a:avLst/>
@@ -5784,8 +6385,8 @@
         </p:nvSpPr>
         <p:spPr>
           <a:xfrm>
-            <a:off x="1981161" y="3840480"/>
-            <a:ext cx="1295361" cy="822960"/>
+            <a:off x="1827072" y="3840480"/>
+            <a:ext cx="1141272" cy="822960"/>
           </a:xfrm>
           <a:prstGeom prst="rect">
             <a:avLst/>
@@ -5824,7 +6425,7 @@
         </p:nvSpPr>
         <p:spPr>
           <a:xfrm>
-            <a:off x="3759612" y="3072384"/>
+            <a:off x="3374390" y="3072384"/>
             <a:ext cx="512064" cy="512064"/>
           </a:xfrm>
           <a:prstGeom prst="ellipse">
@@ -5877,8 +6478,8 @@
         </p:nvSpPr>
         <p:spPr>
           <a:xfrm>
-            <a:off x="3367963" y="2148840"/>
-            <a:ext cx="1295361" cy="411480"/>
+            <a:off x="3059785" y="2148840"/>
+            <a:ext cx="1141272" cy="411480"/>
           </a:xfrm>
           <a:prstGeom prst="rect">
             <a:avLst/>
@@ -5916,8 +6517,8 @@
         </p:nvSpPr>
         <p:spPr>
           <a:xfrm>
-            <a:off x="3367963" y="2560320"/>
-            <a:ext cx="1295361" cy="365760"/>
+            <a:off x="3059785" y="2560320"/>
+            <a:ext cx="1141272" cy="365760"/>
           </a:xfrm>
           <a:prstGeom prst="rect">
             <a:avLst/>
@@ -5955,8 +6556,8 @@
         </p:nvSpPr>
         <p:spPr>
           <a:xfrm>
-            <a:off x="3367963" y="3840480"/>
-            <a:ext cx="1295361" cy="822960"/>
+            <a:off x="3059785" y="3840480"/>
+            <a:ext cx="1141272" cy="822960"/>
           </a:xfrm>
           <a:prstGeom prst="rect">
             <a:avLst/>
@@ -5995,7 +6596,7 @@
         </p:nvSpPr>
         <p:spPr>
           <a:xfrm>
-            <a:off x="5146414" y="3072384"/>
+            <a:off x="4607102" y="3072384"/>
             <a:ext cx="512064" cy="512064"/>
           </a:xfrm>
           <a:prstGeom prst="ellipse">
@@ -6048,8 +6649,8 @@
         </p:nvSpPr>
         <p:spPr>
           <a:xfrm>
-            <a:off x="4754765" y="2148840"/>
-            <a:ext cx="1295361" cy="411480"/>
+            <a:off x="4292498" y="2148840"/>
+            <a:ext cx="1141272" cy="411480"/>
           </a:xfrm>
           <a:prstGeom prst="rect">
             <a:avLst/>
@@ -6087,8 +6688,8 @@
         </p:nvSpPr>
         <p:spPr>
           <a:xfrm>
-            <a:off x="4754765" y="2560320"/>
-            <a:ext cx="1295361" cy="365760"/>
+            <a:off x="4292498" y="2560320"/>
+            <a:ext cx="1141272" cy="365760"/>
           </a:xfrm>
           <a:prstGeom prst="rect">
             <a:avLst/>
@@ -6126,8 +6727,8 @@
         </p:nvSpPr>
         <p:spPr>
           <a:xfrm>
-            <a:off x="4754765" y="3840480"/>
-            <a:ext cx="1295361" cy="822960"/>
+            <a:off x="4292498" y="3840480"/>
+            <a:ext cx="1141272" cy="822960"/>
           </a:xfrm>
           <a:prstGeom prst="rect">
             <a:avLst/>
@@ -6166,7 +6767,7 @@
         </p:nvSpPr>
         <p:spPr>
           <a:xfrm>
-            <a:off x="6533216" y="3072384"/>
+            <a:off x="5839815" y="3072384"/>
             <a:ext cx="512064" cy="512064"/>
           </a:xfrm>
           <a:prstGeom prst="ellipse">
@@ -6219,8 +6820,8 @@
         </p:nvSpPr>
         <p:spPr>
           <a:xfrm>
-            <a:off x="6141567" y="2148840"/>
-            <a:ext cx="1295361" cy="411480"/>
+            <a:off x="5525211" y="2148840"/>
+            <a:ext cx="1141272" cy="411480"/>
           </a:xfrm>
           <a:prstGeom prst="rect">
             <a:avLst/>
@@ -6258,8 +6859,8 @@
         </p:nvSpPr>
         <p:spPr>
           <a:xfrm>
-            <a:off x="6141567" y="2560320"/>
-            <a:ext cx="1295361" cy="365760"/>
+            <a:off x="5525211" y="2560320"/>
+            <a:ext cx="1141272" cy="365760"/>
           </a:xfrm>
           <a:prstGeom prst="rect">
             <a:avLst/>
@@ -6297,8 +6898,8 @@
         </p:nvSpPr>
         <p:spPr>
           <a:xfrm>
-            <a:off x="6141567" y="3840480"/>
-            <a:ext cx="1295361" cy="822960"/>
+            <a:off x="5525211" y="3840480"/>
+            <a:ext cx="1141272" cy="822960"/>
           </a:xfrm>
           <a:prstGeom prst="rect">
             <a:avLst/>
@@ -6337,7 +6938,7 @@
         </p:nvSpPr>
         <p:spPr>
           <a:xfrm>
-            <a:off x="7920018" y="3072384"/>
+            <a:off x="7072528" y="3072384"/>
             <a:ext cx="512064" cy="512064"/>
           </a:xfrm>
           <a:prstGeom prst="ellipse">
@@ -6390,8 +6991,8 @@
         </p:nvSpPr>
         <p:spPr>
           <a:xfrm>
-            <a:off x="7528369" y="2148840"/>
-            <a:ext cx="1295361" cy="411480"/>
+            <a:off x="6757924" y="2148840"/>
+            <a:ext cx="1141272" cy="411480"/>
           </a:xfrm>
           <a:prstGeom prst="rect">
             <a:avLst/>
@@ -6429,8 +7030,8 @@
         </p:nvSpPr>
         <p:spPr>
           <a:xfrm>
-            <a:off x="7528369" y="2560320"/>
-            <a:ext cx="1295361" cy="365760"/>
+            <a:off x="6757924" y="2560320"/>
+            <a:ext cx="1141272" cy="365760"/>
           </a:xfrm>
           <a:prstGeom prst="rect">
             <a:avLst/>
@@ -6468,8 +7069,8 @@
         </p:nvSpPr>
         <p:spPr>
           <a:xfrm>
-            <a:off x="7528369" y="3840480"/>
-            <a:ext cx="1295361" cy="822960"/>
+            <a:off x="6757924" y="3840480"/>
+            <a:ext cx="1141272" cy="822960"/>
           </a:xfrm>
           <a:prstGeom prst="rect">
             <a:avLst/>
@@ -6508,7 +7109,7 @@
         </p:nvSpPr>
         <p:spPr>
           <a:xfrm>
-            <a:off x="9306820" y="3072384"/>
+            <a:off x="8305241" y="3072384"/>
             <a:ext cx="512064" cy="512064"/>
           </a:xfrm>
           <a:prstGeom prst="ellipse">
@@ -6561,8 +7162,8 @@
         </p:nvSpPr>
         <p:spPr>
           <a:xfrm>
-            <a:off x="8915171" y="2148840"/>
-            <a:ext cx="1295361" cy="411480"/>
+            <a:off x="7990636" y="2148840"/>
+            <a:ext cx="1141272" cy="411480"/>
           </a:xfrm>
           <a:prstGeom prst="rect">
             <a:avLst/>
@@ -6600,8 +7201,8 @@
         </p:nvSpPr>
         <p:spPr>
           <a:xfrm>
-            <a:off x="8915171" y="2560320"/>
-            <a:ext cx="1295361" cy="365760"/>
+            <a:off x="7990636" y="2560320"/>
+            <a:ext cx="1141272" cy="365760"/>
           </a:xfrm>
           <a:prstGeom prst="rect">
             <a:avLst/>
@@ -6639,8 +7240,8 @@
         </p:nvSpPr>
         <p:spPr>
           <a:xfrm>
-            <a:off x="8915171" y="3840480"/>
-            <a:ext cx="1295361" cy="822960"/>
+            <a:off x="7990636" y="3840480"/>
+            <a:ext cx="1141272" cy="822960"/>
           </a:xfrm>
           <a:prstGeom prst="rect">
             <a:avLst/>
@@ -6679,7 +7280,7 @@
         </p:nvSpPr>
         <p:spPr>
           <a:xfrm>
-            <a:off x="10693622" y="3072384"/>
+            <a:off x="9537954" y="3072384"/>
             <a:ext cx="512064" cy="512064"/>
           </a:xfrm>
           <a:prstGeom prst="ellipse">
@@ -6732,8 +7333,8 @@
         </p:nvSpPr>
         <p:spPr>
           <a:xfrm>
-            <a:off x="10301973" y="2148840"/>
-            <a:ext cx="1295361" cy="411480"/>
+            <a:off x="9223349" y="2148840"/>
+            <a:ext cx="1141272" cy="411480"/>
           </a:xfrm>
           <a:prstGeom prst="rect">
             <a:avLst/>
@@ -6771,8 +7372,8 @@
         </p:nvSpPr>
         <p:spPr>
           <a:xfrm>
-            <a:off x="10301973" y="2560320"/>
-            <a:ext cx="1295361" cy="365760"/>
+            <a:off x="9223349" y="2560320"/>
+            <a:ext cx="1141272" cy="365760"/>
           </a:xfrm>
           <a:prstGeom prst="rect">
             <a:avLst/>
@@ -6810,8 +7411,8 @@
         </p:nvSpPr>
         <p:spPr>
           <a:xfrm>
-            <a:off x="10301973" y="3840480"/>
-            <a:ext cx="1295361" cy="822960"/>
+            <a:off x="9223349" y="3840480"/>
+            <a:ext cx="1141272" cy="822960"/>
           </a:xfrm>
           <a:prstGeom prst="rect">
             <a:avLst/>
@@ -6844,7 +7445,178 @@
       </p:sp>
       <p:sp>
         <p:nvSpPr>
-          <p:cNvPr id="37" name="TextBox 36"/>
+          <p:cNvPr id="37" name="Oval 36"/>
+          <p:cNvSpPr/>
+          <p:nvPr/>
+        </p:nvSpPr>
+        <p:spPr>
+          <a:xfrm>
+            <a:off x="10770666" y="3072384"/>
+            <a:ext cx="512064" cy="512064"/>
+          </a:xfrm>
+          <a:prstGeom prst="ellipse">
+            <a:avLst/>
+          </a:prstGeom>
+          <a:solidFill>
+            <a:srgbClr val="D1495B"/>
+          </a:solidFill>
+          <a:ln>
+            <a:noFill/>
+          </a:ln>
+          <a:effectLst/>
+        </p:spPr>
+        <p:style>
+          <a:lnRef idx="1">
+            <a:schemeClr val="accent1"/>
+          </a:lnRef>
+          <a:fillRef idx="3">
+            <a:schemeClr val="accent1"/>
+          </a:fillRef>
+          <a:effectRef idx="2">
+            <a:schemeClr val="accent1"/>
+          </a:effectRef>
+          <a:fontRef idx="minor">
+            <a:schemeClr val="lt1"/>
+          </a:fontRef>
+        </p:style>
+        <p:txBody>
+          <a:bodyPr rtlCol="0" anchor="ctr" lIns="0" rIns="0" tIns="0" bIns="0"/>
+          <a:lstStyle/>
+          <a:p>
+            <a:pPr algn="ctr"/>
+            <a:r>
+              <a:rPr sz="1600" b="1">
+                <a:solidFill>
+                  <a:srgbClr val="FFFFFF"/>
+                </a:solidFill>
+                <a:latin typeface="Calibri"/>
+              </a:rPr>
+              <a:t/>
+            </a:r>
+          </a:p>
+        </p:txBody>
+      </p:sp>
+      <p:sp>
+        <p:nvSpPr>
+          <p:cNvPr id="38" name="TextBox 37"/>
+          <p:cNvSpPr txBox="1"/>
+          <p:nvPr/>
+        </p:nvSpPr>
+        <p:spPr>
+          <a:xfrm>
+            <a:off x="10456062" y="2148840"/>
+            <a:ext cx="1141272" cy="411480"/>
+          </a:xfrm>
+          <a:prstGeom prst="rect">
+            <a:avLst/>
+          </a:prstGeom>
+          <a:noFill/>
+        </p:spPr>
+        <p:txBody>
+          <a:bodyPr wrap="square" lIns="0" rIns="0" tIns="0" bIns="0">
+            <a:spAutoFit/>
+          </a:bodyPr>
+          <a:lstStyle/>
+          <a:p>
+            <a:pPr algn="ctr">
+              <a:spcAft>
+                <a:spcPts val="600"/>
+              </a:spcAft>
+            </a:pPr>
+            <a:r>
+              <a:rPr sz="1500" b="1" i="0">
+                <a:solidFill>
+                  <a:srgbClr val="1F3B4D"/>
+                </a:solidFill>
+                <a:latin typeface="Calibri"/>
+              </a:rPr>
+              <a:t>W3c</a:t>
+            </a:r>
+          </a:p>
+        </p:txBody>
+      </p:sp>
+      <p:sp>
+        <p:nvSpPr>
+          <p:cNvPr id="39" name="TextBox 38"/>
+          <p:cNvSpPr txBox="1"/>
+          <p:nvPr/>
+        </p:nvSpPr>
+        <p:spPr>
+          <a:xfrm>
+            <a:off x="10456062" y="2560320"/>
+            <a:ext cx="1141272" cy="365760"/>
+          </a:xfrm>
+          <a:prstGeom prst="rect">
+            <a:avLst/>
+          </a:prstGeom>
+          <a:noFill/>
+        </p:spPr>
+        <p:txBody>
+          <a:bodyPr wrap="square" lIns="0" rIns="0" tIns="0" bIns="0">
+            <a:spAutoFit/>
+          </a:bodyPr>
+          <a:lstStyle/>
+          <a:p>
+            <a:pPr algn="ctr">
+              <a:spcAft>
+                <a:spcPts val="600"/>
+              </a:spcAft>
+            </a:pPr>
+            <a:r>
+              <a:rPr sz="1200" b="1" i="0">
+                <a:solidFill>
+                  <a:srgbClr val="D1495B"/>
+                </a:solidFill>
+                <a:latin typeface="Calibri"/>
+              </a:rPr>
+              <a:t>FAIL</a:t>
+            </a:r>
+          </a:p>
+        </p:txBody>
+      </p:sp>
+      <p:sp>
+        <p:nvSpPr>
+          <p:cNvPr id="40" name="TextBox 39"/>
+          <p:cNvSpPr txBox="1"/>
+          <p:nvPr/>
+        </p:nvSpPr>
+        <p:spPr>
+          <a:xfrm>
+            <a:off x="10456062" y="3840480"/>
+            <a:ext cx="1141272" cy="822960"/>
+          </a:xfrm>
+          <a:prstGeom prst="rect">
+            <a:avLst/>
+          </a:prstGeom>
+          <a:noFill/>
+        </p:spPr>
+        <p:txBody>
+          <a:bodyPr wrap="square" lIns="0" rIns="0" tIns="0" bIns="0">
+            <a:spAutoFit/>
+          </a:bodyPr>
+          <a:lstStyle/>
+          <a:p>
+            <a:pPr algn="ctr">
+              <a:spcAft>
+                <a:spcPts val="600"/>
+              </a:spcAft>
+            </a:pPr>
+            <a:r>
+              <a:rPr sz="1200" b="0" i="0">
+                <a:solidFill>
+                  <a:srgbClr val="5F6B73"/>
+                </a:solidFill>
+                <a:latin typeface="Calibri"/>
+              </a:rPr>
+              <a:t>per-cell validity,
+trained objective</a:t>
+            </a:r>
+          </a:p>
+        </p:txBody>
+      </p:sp>
+      <p:sp>
+        <p:nvSpPr>
+          <p:cNvPr id="41" name="TextBox 40"/>
           <p:cNvSpPr txBox="1"/>
           <p:nvPr/>
         </p:nvSpPr>
@@ -7755,7 +8527,7 @@
                 </a:solidFill>
                 <a:latin typeface="Calibri"/>
               </a:rPr>
-              <a:t>lstm w0.4 s1: 0.098</a:t>
+              <a:t>W3 lstm w0.4 s1: 0.098</a:t>
             </a:r>
           </a:p>
           <a:p>
@@ -7771,7 +8543,7 @@
                 </a:solidFill>
                 <a:latin typeface="Calibri"/>
               </a:rPr>
-              <a:t>ode_rnn w0.0 s0: 0.071</a:t>
+              <a:t>W3 ode_rnn w0.0 s0: 0.071</a:t>
             </a:r>
           </a:p>
           <a:p>
@@ -7787,7 +8559,7 @@
                 </a:solidFill>
                 <a:latin typeface="Calibri"/>
               </a:rPr>
-              <a:t>lstm w0.4 s4: 0.010</a:t>
+              <a:t>W3B lstm w0.4 s4: 0.010</a:t>
             </a:r>
           </a:p>
           <a:p>
@@ -7803,7 +8575,7 @@
                 </a:solidFill>
                 <a:latin typeface="Calibri"/>
               </a:rPr>
-              <a:t>ode_rnn w0.2 s3: 0.011</a:t>
+              <a:t>W3B ode_rnn w0.2 s3: 0.011</a:t>
             </a:r>
           </a:p>
           <a:p>
@@ -7815,11 +8587,59 @@
             <a:r>
               <a:rPr sz="1300" b="0" i="0">
                 <a:solidFill>
+                  <a:srgbClr val="1F3B4D"/>
+                </a:solidFill>
+                <a:latin typeface="Calibri"/>
+              </a:rPr>
+              <a:t>W3C lstm w0.1 s7: 0.095</a:t>
+            </a:r>
+          </a:p>
+          <a:p>
+            <a:pPr algn="l">
+              <a:spcAft>
+                <a:spcPts val="700"/>
+              </a:spcAft>
+            </a:pPr>
+            <a:r>
+              <a:rPr sz="1300" b="0" i="0">
+                <a:solidFill>
+                  <a:srgbClr val="1F3B4D"/>
+                </a:solidFill>
+                <a:latin typeface="Calibri"/>
+              </a:rPr>
+              <a:t>W3C lstm w0.2 s8: 0.068</a:t>
+            </a:r>
+          </a:p>
+          <a:p>
+            <a:pPr algn="l">
+              <a:spcAft>
+                <a:spcPts val="700"/>
+              </a:spcAft>
+            </a:pPr>
+            <a:r>
+              <a:rPr sz="1300" b="0" i="0">
+                <a:solidFill>
+                  <a:srgbClr val="1F3B4D"/>
+                </a:solidFill>
+                <a:latin typeface="Calibri"/>
+              </a:rPr>
+              <a:t>W3C ode_rnn w0.1 s8: 0.096</a:t>
+            </a:r>
+          </a:p>
+          <a:p>
+            <a:pPr algn="l">
+              <a:spcAft>
+                <a:spcPts val="700"/>
+              </a:spcAft>
+            </a:pPr>
+            <a:r>
+              <a:rPr sz="1300" b="0" i="0">
+                <a:solidFill>
                   <a:srgbClr val="D1495B"/>
                 </a:solidFill>
                 <a:latin typeface="Calibri"/>
               </a:rPr>
-              <a:t>The MLP never fails; one recurrent cell in ~14 does — enough to invalidate every registration with an LSTM arm so far.</a:t>
+              <a:t>The MLP never fails; 7 recurrent cells have. W3c's per-cell rule excludes such cells instead of voiding the arm.</a:t>
             </a:r>
           </a:p>
         </p:txBody>
@@ -9533,21 +10353,78 @@
                 </a:solidFill>
                 <a:latin typeface="Cambria"/>
               </a:rPr>
-              <a:t>Four ways this evaluation lied — each now a gate</a:t>
-            </a:r>
-          </a:p>
-        </p:txBody>
-      </p:sp>
-      <p:sp>
-        <p:nvSpPr>
-          <p:cNvPr id="3" name="Rounded Rectangle 2"/>
+              <a:t>W3c: memory hurts, continuous time hurts further</a:t>
+            </a:r>
+          </a:p>
+        </p:txBody>
+      </p:sp>
+      <p:sp>
+        <p:nvSpPr>
+          <p:cNvPr id="3" name="TextBox 2"/>
+          <p:cNvSpPr txBox="1"/>
+          <p:nvPr/>
+        </p:nvSpPr>
+        <p:spPr>
+          <a:xfrm>
+            <a:off x="548640" y="1097280"/>
+            <a:ext cx="11094415" cy="457200"/>
+          </a:xfrm>
+          <a:prstGeom prst="rect">
+            <a:avLst/>
+          </a:prstGeom>
+          <a:noFill/>
+        </p:spPr>
+        <p:txBody>
+          <a:bodyPr wrap="square" lIns="0" rIns="0" tIns="0" bIns="0">
+            <a:spAutoFit/>
+          </a:bodyPr>
+          <a:lstStyle/>
+          <a:p>
+            <a:pPr algn="l">
+              <a:spcAft>
+                <a:spcPts val="600"/>
+              </a:spcAft>
+            </a:pPr>
+            <a:r>
+              <a:rPr sz="1600" b="0" i="1">
+                <a:solidFill>
+                  <a:srgbClr val="5F6B73"/>
+                </a:solidFill>
+                <a:latin typeface="Calibri"/>
+              </a:rPr>
+              <a:t>First valid three-arm run · trained objective U = TTP − w · exposure, paired per patient</a:t>
+            </a:r>
+          </a:p>
+        </p:txBody>
+      </p:sp>
+      <p:graphicFrame>
+        <p:nvGraphicFramePr>
+          <p:cNvPr id="4" name="Chart 3"/>
+          <p:cNvGraphicFramePr>
+            <a:graphicFrameLocks noGrp="1"/>
+          </p:cNvGraphicFramePr>
+          <p:nvPr/>
+        </p:nvGraphicFramePr>
+        <p:xfrm>
+          <a:off x="548640" y="1737360"/>
+          <a:ext cx="6949440" cy="4572000"/>
+        </p:xfrm>
+        <a:graphic>
+          <a:graphicData uri="http://schemas.openxmlformats.org/drawingml/2006/chart">
+            <c:chart xmlns:c="http://schemas.openxmlformats.org/drawingml/2006/chart" r:id="rId3"/>
+          </a:graphicData>
+        </a:graphic>
+      </p:graphicFrame>
+      <p:sp>
+        <p:nvSpPr>
+          <p:cNvPr id="5" name="Rounded Rectangle 4"/>
           <p:cNvSpPr/>
           <p:nvPr/>
         </p:nvSpPr>
         <p:spPr>
           <a:xfrm>
-            <a:off x="548640" y="1417320"/>
-            <a:ext cx="5349240" cy="2286000"/>
+            <a:off x="7863840" y="1737360"/>
+            <a:ext cx="3794760" cy="4572000"/>
           </a:xfrm>
           <a:prstGeom prst="roundRect">
             <a:avLst>
@@ -9586,67 +10463,14 @@
       </p:sp>
       <p:sp>
         <p:nvSpPr>
-          <p:cNvPr id="4" name="Oval 3"/>
-          <p:cNvSpPr/>
-          <p:nvPr/>
-        </p:nvSpPr>
-        <p:spPr>
-          <a:xfrm>
-            <a:off x="822959" y="1691640"/>
-            <a:ext cx="457200" cy="457200"/>
-          </a:xfrm>
-          <a:prstGeom prst="ellipse">
-            <a:avLst/>
-          </a:prstGeom>
-          <a:solidFill>
-            <a:srgbClr val="D1495B"/>
-          </a:solidFill>
-          <a:ln>
-            <a:noFill/>
-          </a:ln>
-          <a:effectLst/>
-        </p:spPr>
-        <p:style>
-          <a:lnRef idx="1">
-            <a:schemeClr val="accent1"/>
-          </a:lnRef>
-          <a:fillRef idx="3">
-            <a:schemeClr val="accent1"/>
-          </a:fillRef>
-          <a:effectRef idx="2">
-            <a:schemeClr val="accent1"/>
-          </a:effectRef>
-          <a:fontRef idx="minor">
-            <a:schemeClr val="lt1"/>
-          </a:fontRef>
-        </p:style>
-        <p:txBody>
-          <a:bodyPr rtlCol="0" anchor="ctr" lIns="0" rIns="0" tIns="0" bIns="0"/>
-          <a:lstStyle/>
-          <a:p>
-            <a:pPr algn="ctr"/>
-            <a:r>
-              <a:rPr sz="1600" b="1">
-                <a:solidFill>
-                  <a:srgbClr val="FFFFFF"/>
-                </a:solidFill>
-                <a:latin typeface="Calibri"/>
-              </a:rPr>
-              <a:t>1</a:t>
-            </a:r>
-          </a:p>
-        </p:txBody>
-      </p:sp>
-      <p:sp>
-        <p:nvSpPr>
-          <p:cNvPr id="5" name="TextBox 4"/>
+          <p:cNvPr id="6" name="TextBox 5"/>
           <p:cNvSpPr txBox="1"/>
           <p:nvPr/>
         </p:nvSpPr>
         <p:spPr>
           <a:xfrm>
-            <a:off x="1463040" y="1709928"/>
-            <a:ext cx="4206240" cy="457200"/>
+            <a:off x="8092440" y="1920240"/>
+            <a:ext cx="3383280" cy="4297680"/>
           </a:xfrm>
           <a:prstGeom prst="rect">
             <a:avLst/>
@@ -9665,38 +10489,40 @@
               </a:spcAft>
             </a:pPr>
             <a:r>
-              <a:rPr sz="1800" b="1" i="0">
+              <a:rPr sz="1600" b="1" i="0">
                 <a:solidFill>
                   <a:srgbClr val="1F3B4D"/>
                 </a:solidFill>
+                <a:latin typeface="Calibri"/>
+              </a:rPr>
+              <a:t>Memory: LSTM − MLP</a:t>
+            </a:r>
+          </a:p>
+          <a:p>
+            <a:pPr algn="l">
+              <a:spcAft>
+                <a:spcPts val="600"/>
+              </a:spcAft>
+            </a:pPr>
+            <a:r>
+              <a:rPr sz="2600" b="1" i="0">
+                <a:solidFill>
+                  <a:srgbClr val="D1495B"/>
+                </a:solidFill>
                 <a:latin typeface="Cambria"/>
               </a:rPr>
-              <a:t>An open-loop schedule</a:t>
-            </a:r>
-          </a:p>
-        </p:txBody>
-      </p:sp>
-      <p:sp>
-        <p:nvSpPr>
-          <p:cNvPr id="6" name="TextBox 5"/>
-          <p:cNvSpPr txBox="1"/>
-          <p:nvPr/>
-        </p:nvSpPr>
-        <p:spPr>
-          <a:xfrm>
-            <a:off x="822959" y="2286000"/>
-            <a:ext cx="4800600" cy="868680"/>
-          </a:xfrm>
-          <a:prstGeom prst="rect">
-            <a:avLst/>
-          </a:prstGeom>
-          <a:noFill/>
-        </p:spPr>
-        <p:txBody>
-          <a:bodyPr wrap="square" lIns="0" rIns="0" tIns="0" bIns="0">
-            <a:spAutoFit/>
-          </a:bodyPr>
-          <a:lstStyle/>
+              <a:t>-82.9 d</a:t>
+            </a:r>
+            <a:r>
+              <a:rPr sz="1300" b="0" i="0">
+                <a:solidFill>
+                  <a:srgbClr val="1F3B4D"/>
+                </a:solidFill>
+                <a:latin typeface="Calibri"/>
+              </a:rPr>
+              <a:t>  [-88, -78] Tier 1</a:t>
+            </a:r>
+          </a:p>
           <a:p>
             <a:pPr algn="l">
               <a:spcAft>
@@ -9706,36 +10532,13 @@
             <a:r>
               <a:rPr sz="1300" b="0" i="0">
                 <a:solidFill>
-                  <a:srgbClr val="5F6B73"/>
-                </a:solidFill>
-                <a:latin typeface="Calibri"/>
-              </a:rPr>
-              <a:t>The ODE-RNN gave all 200 patients one identical dosing history and still reported a respectable TTP (L312).</a:t>
-            </a:r>
-          </a:p>
-        </p:txBody>
-      </p:sp>
-      <p:sp>
-        <p:nvSpPr>
-          <p:cNvPr id="7" name="TextBox 6"/>
-          <p:cNvSpPr txBox="1"/>
-          <p:nvPr/>
-        </p:nvSpPr>
-        <p:spPr>
-          <a:xfrm>
-            <a:off x="822959" y="3154680"/>
-            <a:ext cx="4800600" cy="411480"/>
-          </a:xfrm>
-          <a:prstGeom prst="rect">
-            <a:avLst/>
-          </a:prstGeom>
-          <a:noFill/>
-        </p:spPr>
-        <p:txBody>
-          <a:bodyPr wrap="square" lIns="0" rIns="0" tIns="0" bIns="0">
-            <a:spAutoFit/>
-          </a:bodyPr>
-          <a:lstStyle/>
+                  <a:srgbClr val="1F3B4D"/>
+                </a:solidFill>
+                <a:latin typeface="Calibri"/>
+              </a:rPr>
+              <a:t>Tier 0: -73.5 d · FAILS</a:t>
+            </a:r>
+          </a:p>
           <a:p>
             <a:pPr algn="l">
               <a:spcAft>
@@ -9743,13 +10546,70 @@
               </a:spcAft>
             </a:pPr>
             <a:r>
+              <a:rPr sz="1600" b="1" i="0">
+                <a:solidFill>
+                  <a:srgbClr val="1F3B4D"/>
+                </a:solidFill>
+                <a:latin typeface="Calibri"/>
+              </a:rPr>
+              <a:t>Continuous time: ODE − LSTM</a:t>
+            </a:r>
+          </a:p>
+          <a:p>
+            <a:pPr algn="l">
+              <a:spcAft>
+                <a:spcPts val="600"/>
+              </a:spcAft>
+            </a:pPr>
+            <a:r>
+              <a:rPr sz="2600" b="1" i="0">
+                <a:solidFill>
+                  <a:srgbClr val="D1495B"/>
+                </a:solidFill>
+                <a:latin typeface="Cambria"/>
+              </a:rPr>
+              <a:t>-15.7 d</a:t>
+            </a:r>
+            <a:r>
+              <a:rPr sz="1300" b="0" i="0">
+                <a:solidFill>
+                  <a:srgbClr val="1F3B4D"/>
+                </a:solidFill>
+                <a:latin typeface="Calibri"/>
+              </a:rPr>
+              <a:t>  [-20, -11] Tier 1</a:t>
+            </a:r>
+          </a:p>
+          <a:p>
+            <a:pPr algn="l">
+              <a:spcAft>
+                <a:spcPts val="600"/>
+              </a:spcAft>
+            </a:pPr>
+            <a:r>
+              <a:rPr sz="1300" b="0" i="0">
+                <a:solidFill>
+                  <a:srgbClr val="1F3B4D"/>
+                </a:solidFill>
+                <a:latin typeface="Calibri"/>
+              </a:rPr>
+              <a:t>Tier 0: -16.7 d · FAILS</a:t>
+            </a:r>
+          </a:p>
+          <a:p>
+            <a:pPr algn="l">
+              <a:spcAft>
+                <a:spcPts val="600"/>
+              </a:spcAft>
+            </a:pPr>
+            <a:r>
               <a:rPr sz="1300" b="1" i="0">
                 <a:solidFill>
-                  <a:srgbClr val="2A9D8F"/>
-                </a:solidFill>
-                <a:latin typeface="Calibri"/>
-              </a:rPr>
-              <a:t>Fix: </a:t>
+                  <a:srgbClr val="1F3B4D"/>
+                </a:solidFill>
+                <a:latin typeface="Calibri"/>
+              </a:rPr>
+              <a:t>Excluded cells: </a:t>
             </a:r>
             <a:r>
               <a:rPr sz="1300" b="0" i="0">
@@ -9758,131 +10618,9 @@
                 </a:solidFill>
                 <a:latin typeface="Calibri"/>
               </a:rPr>
-              <a:t>closed-loop validity ≥ 0.10 per cell</a:t>
-            </a:r>
-          </a:p>
-        </p:txBody>
-      </p:sp>
-      <p:sp>
-        <p:nvSpPr>
-          <p:cNvPr id="8" name="Rounded Rectangle 7"/>
-          <p:cNvSpPr/>
-          <p:nvPr/>
-        </p:nvSpPr>
-        <p:spPr>
-          <a:xfrm>
-            <a:off x="6217920" y="1417320"/>
-            <a:ext cx="5349240" cy="2286000"/>
-          </a:xfrm>
-          <a:prstGeom prst="roundRect">
-            <a:avLst>
-              <a:gd name="adj" fmla="val 6000"/>
-            </a:avLst>
-          </a:prstGeom>
-          <a:solidFill>
-            <a:srgbClr val="EEF3F5"/>
-          </a:solidFill>
-          <a:ln>
-            <a:noFill/>
-          </a:ln>
-          <a:effectLst/>
-        </p:spPr>
-        <p:style>
-          <a:lnRef idx="1">
-            <a:schemeClr val="accent1"/>
-          </a:lnRef>
-          <a:fillRef idx="3">
-            <a:schemeClr val="accent1"/>
-          </a:fillRef>
-          <a:effectRef idx="2">
-            <a:schemeClr val="accent1"/>
-          </a:effectRef>
-          <a:fontRef idx="minor">
-            <a:schemeClr val="lt1"/>
-          </a:fontRef>
-        </p:style>
-        <p:txBody>
-          <a:bodyPr rtlCol="0" anchor="ctr"/>
-          <a:lstStyle/>
-          <a:p>
-            <a:pPr algn="ctr"/>
-          </a:p>
-        </p:txBody>
-      </p:sp>
-      <p:sp>
-        <p:nvSpPr>
-          <p:cNvPr id="9" name="Oval 8"/>
-          <p:cNvSpPr/>
-          <p:nvPr/>
-        </p:nvSpPr>
-        <p:spPr>
-          <a:xfrm>
-            <a:off x="6492240" y="1691640"/>
-            <a:ext cx="457200" cy="457200"/>
-          </a:xfrm>
-          <a:prstGeom prst="ellipse">
-            <a:avLst/>
-          </a:prstGeom>
-          <a:solidFill>
-            <a:srgbClr val="D1495B"/>
-          </a:solidFill>
-          <a:ln>
-            <a:noFill/>
-          </a:ln>
-          <a:effectLst/>
-        </p:spPr>
-        <p:style>
-          <a:lnRef idx="1">
-            <a:schemeClr val="accent1"/>
-          </a:lnRef>
-          <a:fillRef idx="3">
-            <a:schemeClr val="accent1"/>
-          </a:fillRef>
-          <a:effectRef idx="2">
-            <a:schemeClr val="accent1"/>
-          </a:effectRef>
-          <a:fontRef idx="minor">
-            <a:schemeClr val="lt1"/>
-          </a:fontRef>
-        </p:style>
-        <p:txBody>
-          <a:bodyPr rtlCol="0" anchor="ctr" lIns="0" rIns="0" tIns="0" bIns="0"/>
-          <a:lstStyle/>
-          <a:p>
-            <a:pPr algn="ctr"/>
-            <a:r>
-              <a:rPr sz="1600" b="1">
-                <a:solidFill>
-                  <a:srgbClr val="FFFFFF"/>
-                </a:solidFill>
-                <a:latin typeface="Calibri"/>
-              </a:rPr>
-              <a:t>2</a:t>
-            </a:r>
-          </a:p>
-        </p:txBody>
-      </p:sp>
-      <p:sp>
-        <p:nvSpPr>
-          <p:cNvPr id="10" name="TextBox 9"/>
-          <p:cNvSpPr txBox="1"/>
-          <p:nvPr/>
-        </p:nvSpPr>
-        <p:spPr>
-          <a:xfrm>
-            <a:off x="7132320" y="1709928"/>
-            <a:ext cx="4206240" cy="457200"/>
-          </a:xfrm>
-          <a:prstGeom prst="rect">
-            <a:avLst/>
-          </a:prstGeom>
-          <a:noFill/>
-        </p:spPr>
-        <p:txBody>
-          <a:bodyPr wrap="square" lIns="0" rIns="0" tIns="0" bIns="0">
-            <a:spAutoFit/>
-          </a:bodyPr>
-          <a:lstStyle/>
+              <a:t>3/60, none from the MLP</a:t>
+            </a:r>
+          </a:p>
           <a:p>
             <a:pPr algn="l">
               <a:spcAft>
@@ -9890,550 +10628,13 @@
               </a:spcAft>
             </a:pPr>
             <a:r>
-              <a:rPr sz="1800" b="1" i="0">
-                <a:solidFill>
-                  <a:srgbClr val="1F3B4D"/>
-                </a:solidFill>
-                <a:latin typeface="Cambria"/>
-              </a:rPr>
-              <a:t>The progressor-only median</a:t>
-            </a:r>
-          </a:p>
-        </p:txBody>
-      </p:sp>
-      <p:sp>
-        <p:nvSpPr>
-          <p:cNvPr id="11" name="TextBox 10"/>
-          <p:cNvSpPr txBox="1"/>
-          <p:nvPr/>
-        </p:nvSpPr>
-        <p:spPr>
-          <a:xfrm>
-            <a:off x="6492240" y="2286000"/>
-            <a:ext cx="4800600" cy="868680"/>
-          </a:xfrm>
-          <a:prstGeom prst="rect">
-            <a:avLst/>
-          </a:prstGeom>
-          <a:noFill/>
-        </p:spPr>
-        <p:txBody>
-          <a:bodyPr wrap="square" lIns="0" rIns="0" tIns="0" bIns="0">
-            <a:spAutoFit/>
-          </a:bodyPr>
-          <a:lstStyle/>
-          <a:p>
-            <a:pPr algn="l">
-              <a:spcAft>
-                <a:spcPts val="600"/>
-              </a:spcAft>
-            </a:pPr>
-            <a:r>
-              <a:rPr sz="1300" b="0" i="0">
-                <a:solidFill>
-                  <a:srgbClr val="5F6B73"/>
-                </a:solidFill>
-                <a:latin typeface="Calibri"/>
-              </a:rPr>
-              <a:t>Averaging only patients who progress rewards letting more of them progress; it inverted the paired result 3 times.</a:t>
-            </a:r>
-          </a:p>
-        </p:txBody>
-      </p:sp>
-      <p:sp>
-        <p:nvSpPr>
-          <p:cNvPr id="12" name="TextBox 11"/>
-          <p:cNvSpPr txBox="1"/>
-          <p:nvPr/>
-        </p:nvSpPr>
-        <p:spPr>
-          <a:xfrm>
-            <a:off x="6492240" y="3154680"/>
-            <a:ext cx="4800600" cy="411480"/>
-          </a:xfrm>
-          <a:prstGeom prst="rect">
-            <a:avLst/>
-          </a:prstGeom>
-          <a:noFill/>
-        </p:spPr>
-        <p:txBody>
-          <a:bodyPr wrap="square" lIns="0" rIns="0" tIns="0" bIns="0">
-            <a:spAutoFit/>
-          </a:bodyPr>
-          <a:lstStyle/>
-          <a:p>
-            <a:pPr algn="l">
-              <a:spcAft>
-                <a:spcPts val="600"/>
-              </a:spcAft>
-            </a:pPr>
-            <a:r>
               <a:rPr sz="1300" b="1" i="0">
                 <a:solidFill>
-                  <a:srgbClr val="2A9D8F"/>
-                </a:solidFill>
-                <a:latin typeface="Calibri"/>
-              </a:rPr>
-              <a:t>Fix: </a:t>
-            </a:r>
-            <a:r>
-              <a:rPr sz="1300" b="0" i="0">
-                <a:solidFill>
-                  <a:srgbClr val="1F3B4D"/>
-                </a:solidFill>
-                <a:latin typeface="Calibri"/>
-              </a:rPr>
-              <a:t>min(TTP, horizon) over all patients</a:t>
-            </a:r>
-          </a:p>
-        </p:txBody>
-      </p:sp>
-      <p:sp>
-        <p:nvSpPr>
-          <p:cNvPr id="13" name="Rounded Rectangle 12"/>
-          <p:cNvSpPr/>
-          <p:nvPr/>
-        </p:nvSpPr>
-        <p:spPr>
-          <a:xfrm>
-            <a:off x="548640" y="3931920"/>
-            <a:ext cx="5349240" cy="2286000"/>
-          </a:xfrm>
-          <a:prstGeom prst="roundRect">
-            <a:avLst>
-              <a:gd name="adj" fmla="val 6000"/>
-            </a:avLst>
-          </a:prstGeom>
-          <a:solidFill>
-            <a:srgbClr val="EEF3F5"/>
-          </a:solidFill>
-          <a:ln>
-            <a:noFill/>
-          </a:ln>
-          <a:effectLst/>
-        </p:spPr>
-        <p:style>
-          <a:lnRef idx="1">
-            <a:schemeClr val="accent1"/>
-          </a:lnRef>
-          <a:fillRef idx="3">
-            <a:schemeClr val="accent1"/>
-          </a:fillRef>
-          <a:effectRef idx="2">
-            <a:schemeClr val="accent1"/>
-          </a:effectRef>
-          <a:fontRef idx="minor">
-            <a:schemeClr val="lt1"/>
-          </a:fontRef>
-        </p:style>
-        <p:txBody>
-          <a:bodyPr rtlCol="0" anchor="ctr"/>
-          <a:lstStyle/>
-          <a:p>
-            <a:pPr algn="ctr"/>
-          </a:p>
-        </p:txBody>
-      </p:sp>
-      <p:sp>
-        <p:nvSpPr>
-          <p:cNvPr id="14" name="Oval 13"/>
-          <p:cNvSpPr/>
-          <p:nvPr/>
-        </p:nvSpPr>
-        <p:spPr>
-          <a:xfrm>
-            <a:off x="822959" y="4206240"/>
-            <a:ext cx="457200" cy="457200"/>
-          </a:xfrm>
-          <a:prstGeom prst="ellipse">
-            <a:avLst/>
-          </a:prstGeom>
-          <a:solidFill>
-            <a:srgbClr val="D1495B"/>
-          </a:solidFill>
-          <a:ln>
-            <a:noFill/>
-          </a:ln>
-          <a:effectLst/>
-        </p:spPr>
-        <p:style>
-          <a:lnRef idx="1">
-            <a:schemeClr val="accent1"/>
-          </a:lnRef>
-          <a:fillRef idx="3">
-            <a:schemeClr val="accent1"/>
-          </a:fillRef>
-          <a:effectRef idx="2">
-            <a:schemeClr val="accent1"/>
-          </a:effectRef>
-          <a:fontRef idx="minor">
-            <a:schemeClr val="lt1"/>
-          </a:fontRef>
-        </p:style>
-        <p:txBody>
-          <a:bodyPr rtlCol="0" anchor="ctr" lIns="0" rIns="0" tIns="0" bIns="0"/>
-          <a:lstStyle/>
-          <a:p>
-            <a:pPr algn="ctr"/>
-            <a:r>
-              <a:rPr sz="1600" b="1">
-                <a:solidFill>
-                  <a:srgbClr val="FFFFFF"/>
-                </a:solidFill>
-                <a:latin typeface="Calibri"/>
-              </a:rPr>
-              <a:t>3</a:t>
-            </a:r>
-          </a:p>
-        </p:txBody>
-      </p:sp>
-      <p:sp>
-        <p:nvSpPr>
-          <p:cNvPr id="15" name="TextBox 14"/>
-          <p:cNvSpPr txBox="1"/>
-          <p:nvPr/>
-        </p:nvSpPr>
-        <p:spPr>
-          <a:xfrm>
-            <a:off x="1463040" y="4224528"/>
-            <a:ext cx="4206240" cy="457200"/>
-          </a:xfrm>
-          <a:prstGeom prst="rect">
-            <a:avLst/>
-          </a:prstGeom>
-          <a:noFill/>
-        </p:spPr>
-        <p:txBody>
-          <a:bodyPr wrap="square" lIns="0" rIns="0" tIns="0" bIns="0">
-            <a:spAutoFit/>
-          </a:bodyPr>
-          <a:lstStyle/>
-          <a:p>
-            <a:pPr algn="l">
-              <a:spcAft>
-                <a:spcPts val="600"/>
-              </a:spcAft>
-            </a:pPr>
-            <a:r>
-              <a:rPr sz="1800" b="1" i="0">
-                <a:solidFill>
-                  <a:srgbClr val="1F3B4D"/>
-                </a:solidFill>
-                <a:latin typeface="Cambria"/>
-              </a:rPr>
-              <a:t>A mis-built shifted cohort</a:t>
-            </a:r>
-          </a:p>
-        </p:txBody>
-      </p:sp>
-      <p:sp>
-        <p:nvSpPr>
-          <p:cNvPr id="16" name="TextBox 15"/>
-          <p:cNvSpPr txBox="1"/>
-          <p:nvPr/>
-        </p:nvSpPr>
-        <p:spPr>
-          <a:xfrm>
-            <a:off x="822959" y="4800600"/>
-            <a:ext cx="4800600" cy="868680"/>
-          </a:xfrm>
-          <a:prstGeom prst="rect">
-            <a:avLst/>
-          </a:prstGeom>
-          <a:noFill/>
-        </p:spPr>
-        <p:txBody>
-          <a:bodyPr wrap="square" lIns="0" rIns="0" tIns="0" bIns="0">
-            <a:spAutoFit/>
-          </a:bodyPr>
-          <a:lstStyle/>
-          <a:p>
-            <a:pPr algn="l">
-              <a:spcAft>
-                <a:spcPts val="600"/>
-              </a:spcAft>
-            </a:pPr>
-            <a:r>
-              <a:rPr sz="1300" b="0" i="0">
-                <a:solidFill>
-                  <a:srgbClr val="5F6B73"/>
-                </a:solidFill>
-                <a:latin typeface="Calibri"/>
-              </a:rPr>
-              <a:t>Scaling K after building y0 put half the test cohort above capacity; NaN blow-ups scored as 'never progressed' (L242).</a:t>
-            </a:r>
-          </a:p>
-        </p:txBody>
-      </p:sp>
-      <p:sp>
-        <p:nvSpPr>
-          <p:cNvPr id="17" name="TextBox 16"/>
-          <p:cNvSpPr txBox="1"/>
-          <p:nvPr/>
-        </p:nvSpPr>
-        <p:spPr>
-          <a:xfrm>
-            <a:off x="822959" y="5669279"/>
-            <a:ext cx="4800600" cy="411480"/>
-          </a:xfrm>
-          <a:prstGeom prst="rect">
-            <a:avLst/>
-          </a:prstGeom>
-          <a:noFill/>
-        </p:spPr>
-        <p:txBody>
-          <a:bodyPr wrap="square" lIns="0" rIns="0" tIns="0" bIns="0">
-            <a:spAutoFit/>
-          </a:bodyPr>
-          <a:lstStyle/>
-          <a:p>
-            <a:pPr algn="l">
-              <a:spcAft>
-                <a:spcPts val="600"/>
-              </a:spcAft>
-            </a:pPr>
-            <a:r>
-              <a:rPr sz="1300" b="1" i="0">
-                <a:solidFill>
-                  <a:srgbClr val="2A9D8F"/>
-                </a:solidFill>
-                <a:latin typeface="Calibri"/>
-              </a:rPr>
-              <a:t>Fix: </a:t>
-            </a:r>
-            <a:r>
-              <a:rPr sz="1300" b="0" i="0">
-                <a:solidFill>
-                  <a:srgbClr val="1F3B4D"/>
-                </a:solidFill>
-                <a:latin typeface="Calibri"/>
-              </a:rPr>
-              <a:t>rebuild y0 from shifted θ; refuse NaN</a:t>
-            </a:r>
-          </a:p>
-        </p:txBody>
-      </p:sp>
-      <p:sp>
-        <p:nvSpPr>
-          <p:cNvPr id="18" name="Rounded Rectangle 17"/>
-          <p:cNvSpPr/>
-          <p:nvPr/>
-        </p:nvSpPr>
-        <p:spPr>
-          <a:xfrm>
-            <a:off x="6217920" y="3931920"/>
-            <a:ext cx="5349240" cy="2286000"/>
-          </a:xfrm>
-          <a:prstGeom prst="roundRect">
-            <a:avLst>
-              <a:gd name="adj" fmla="val 6000"/>
-            </a:avLst>
-          </a:prstGeom>
-          <a:solidFill>
-            <a:srgbClr val="EEF3F5"/>
-          </a:solidFill>
-          <a:ln>
-            <a:noFill/>
-          </a:ln>
-          <a:effectLst/>
-        </p:spPr>
-        <p:style>
-          <a:lnRef idx="1">
-            <a:schemeClr val="accent1"/>
-          </a:lnRef>
-          <a:fillRef idx="3">
-            <a:schemeClr val="accent1"/>
-          </a:fillRef>
-          <a:effectRef idx="2">
-            <a:schemeClr val="accent1"/>
-          </a:effectRef>
-          <a:fontRef idx="minor">
-            <a:schemeClr val="lt1"/>
-          </a:fontRef>
-        </p:style>
-        <p:txBody>
-          <a:bodyPr rtlCol="0" anchor="ctr"/>
-          <a:lstStyle/>
-          <a:p>
-            <a:pPr algn="ctr"/>
-          </a:p>
-        </p:txBody>
-      </p:sp>
-      <p:sp>
-        <p:nvSpPr>
-          <p:cNvPr id="19" name="Oval 18"/>
-          <p:cNvSpPr/>
-          <p:nvPr/>
-        </p:nvSpPr>
-        <p:spPr>
-          <a:xfrm>
-            <a:off x="6492240" y="4206240"/>
-            <a:ext cx="457200" cy="457200"/>
-          </a:xfrm>
-          <a:prstGeom prst="ellipse">
-            <a:avLst/>
-          </a:prstGeom>
-          <a:solidFill>
-            <a:srgbClr val="D1495B"/>
-          </a:solidFill>
-          <a:ln>
-            <a:noFill/>
-          </a:ln>
-          <a:effectLst/>
-        </p:spPr>
-        <p:style>
-          <a:lnRef idx="1">
-            <a:schemeClr val="accent1"/>
-          </a:lnRef>
-          <a:fillRef idx="3">
-            <a:schemeClr val="accent1"/>
-          </a:fillRef>
-          <a:effectRef idx="2">
-            <a:schemeClr val="accent1"/>
-          </a:effectRef>
-          <a:fontRef idx="minor">
-            <a:schemeClr val="lt1"/>
-          </a:fontRef>
-        </p:style>
-        <p:txBody>
-          <a:bodyPr rtlCol="0" anchor="ctr" lIns="0" rIns="0" tIns="0" bIns="0"/>
-          <a:lstStyle/>
-          <a:p>
-            <a:pPr algn="ctr"/>
-            <a:r>
-              <a:rPr sz="1600" b="1">
-                <a:solidFill>
-                  <a:srgbClr val="FFFFFF"/>
-                </a:solidFill>
-                <a:latin typeface="Calibri"/>
-              </a:rPr>
-              <a:t>4</a:t>
-            </a:r>
-          </a:p>
-        </p:txBody>
-      </p:sp>
-      <p:sp>
-        <p:nvSpPr>
-          <p:cNvPr id="20" name="TextBox 19"/>
-          <p:cNvSpPr txBox="1"/>
-          <p:nvPr/>
-        </p:nvSpPr>
-        <p:spPr>
-          <a:xfrm>
-            <a:off x="7132320" y="4224528"/>
-            <a:ext cx="4206240" cy="457200"/>
-          </a:xfrm>
-          <a:prstGeom prst="rect">
-            <a:avLst/>
-          </a:prstGeom>
-          <a:noFill/>
-        </p:spPr>
-        <p:txBody>
-          <a:bodyPr wrap="square" lIns="0" rIns="0" tIns="0" bIns="0">
-            <a:spAutoFit/>
-          </a:bodyPr>
-          <a:lstStyle/>
-          <a:p>
-            <a:pPr algn="l">
-              <a:spcAft>
-                <a:spcPts val="600"/>
-              </a:spcAft>
-            </a:pPr>
-            <a:r>
-              <a:rPr sz="1800" b="1" i="0">
-                <a:solidFill>
-                  <a:srgbClr val="1F3B4D"/>
-                </a:solidFill>
-                <a:latin typeface="Cambria"/>
-              </a:rPr>
-              <a:t>A metric at its ceiling</a:t>
-            </a:r>
-          </a:p>
-        </p:txBody>
-      </p:sp>
-      <p:sp>
-        <p:nvSpPr>
-          <p:cNvPr id="21" name="TextBox 20"/>
-          <p:cNvSpPr txBox="1"/>
-          <p:nvPr/>
-        </p:nvSpPr>
-        <p:spPr>
-          <a:xfrm>
-            <a:off x="6492240" y="4800600"/>
-            <a:ext cx="4800600" cy="868680"/>
-          </a:xfrm>
-          <a:prstGeom prst="rect">
-            <a:avLst/>
-          </a:prstGeom>
-          <a:noFill/>
-        </p:spPr>
-        <p:txBody>
-          <a:bodyPr wrap="square" lIns="0" rIns="0" tIns="0" bIns="0">
-            <a:spAutoFit/>
-          </a:bodyPr>
-          <a:lstStyle/>
-          <a:p>
-            <a:pPr algn="l">
-              <a:spcAft>
-                <a:spcPts val="600"/>
-              </a:spcAft>
-            </a:pPr>
-            <a:r>
-              <a:rPr sz="1300" b="0" i="0">
-                <a:solidFill>
-                  <a:srgbClr val="5F6B73"/>
-                </a:solidFill>
-                <a:latin typeface="Calibri"/>
-              </a:rPr>
-              <a:t>Once &gt; 50% never progress, a capped median is flat at the horizon and ranks nothing (L496).</a:t>
-            </a:r>
-          </a:p>
-        </p:txBody>
-      </p:sp>
-      <p:sp>
-        <p:nvSpPr>
-          <p:cNvPr id="22" name="TextBox 21"/>
-          <p:cNvSpPr txBox="1"/>
-          <p:nvPr/>
-        </p:nvSpPr>
-        <p:spPr>
-          <a:xfrm>
-            <a:off x="6492240" y="5669279"/>
-            <a:ext cx="4800600" cy="411480"/>
-          </a:xfrm>
-          <a:prstGeom prst="rect">
-            <a:avLst/>
-          </a:prstGeom>
-          <a:noFill/>
-        </p:spPr>
-        <p:txBody>
-          <a:bodyPr wrap="square" lIns="0" rIns="0" tIns="0" bIns="0">
-            <a:spAutoFit/>
-          </a:bodyPr>
-          <a:lstStyle/>
-          <a:p>
-            <a:pPr algn="l">
-              <a:spcAft>
-                <a:spcPts val="600"/>
-              </a:spcAft>
-            </a:pPr>
-            <a:r>
-              <a:rPr sz="1300" b="1" i="0">
-                <a:solidFill>
-                  <a:srgbClr val="2A9D8F"/>
-                </a:solidFill>
-                <a:latin typeface="Calibri"/>
-              </a:rPr>
-              <a:t>Fix: </a:t>
-            </a:r>
-            <a:r>
-              <a:rPr sz="1300" b="0" i="0">
-                <a:solidFill>
-                  <a:srgbClr val="1F3B4D"/>
-                </a:solidFill>
-                <a:latin typeface="Calibri"/>
-              </a:rPr>
-              <a:t>restricted-mean TTP (W3b)</a:t>
+                  <a:srgbClr val="D1495B"/>
+                </a:solidFill>
+                <a:latin typeface="Calibri"/>
+              </a:rPr>
+              <a:t>The MLP only ties the one-line 0.8 × baseline rule.</a:t>
             </a:r>
           </a:p>
         </p:txBody>
@@ -10452,7 +10653,7 @@
     <p:bg>
       <p:bgPr>
         <a:solidFill>
-          <a:srgbClr val="1F3B4D"/>
+          <a:srgbClr val="FFFFFF"/>
         </a:solidFill>
         <a:effectLst/>
       </p:bgPr>
@@ -10494,11 +10695,11 @@
             <a:r>
               <a:rPr sz="3400" b="1" i="0">
                 <a:solidFill>
-                  <a:srgbClr val="FFFFFF"/>
+                  <a:srgbClr val="1F3B4D"/>
                 </a:solidFill>
                 <a:latin typeface="Cambria"/>
               </a:rPr>
-              <a:t>Next</a:t>
+              <a:t>W3c per exposure weight</a:t>
             </a:r>
           </a:p>
         </p:txBody>
@@ -10533,12 +10734,186 @@
             <a:r>
               <a:rPr sz="1600" b="0" i="1">
                 <a:solidFill>
-                  <a:srgbClr val="EEF3F5"/>
-                </a:solidFill>
-                <a:latin typeface="Calibri"/>
-              </a:rPr>
-              <a:t>Target: ICLR 2027 workshop — a clean negative is still the paper</a:t>
-            </a:r>
+                  <a:srgbClr val="5F6B73"/>
+                </a:solidFill>
+                <a:latin typeface="Calibri"/>
+              </a:rPr>
+              <a:t>Dashed = fixed rules, solid = trained policies</a:t>
+            </a:r>
+          </a:p>
+        </p:txBody>
+      </p:sp>
+      <p:pic>
+        <p:nvPicPr>
+          <p:cNvPr id="4" name="Picture 3" descr="09_w3c_utility.png"/>
+          <p:cNvPicPr>
+            <a:picLocks noChangeAspect="1"/>
+          </p:cNvPicPr>
+          <p:nvPr/>
+        </p:nvPicPr>
+        <p:blipFill>
+          <a:blip r:embed="rId3"/>
+          <a:stretch>
+            <a:fillRect/>
+          </a:stretch>
+        </p:blipFill>
+        <p:spPr>
+          <a:xfrm>
+            <a:off x="548640" y="1731873"/>
+            <a:ext cx="11094415" cy="4034332"/>
+          </a:xfrm>
+          <a:prstGeom prst="rect">
+            <a:avLst/>
+          </a:prstGeom>
+        </p:spPr>
+      </p:pic>
+      <p:sp>
+        <p:nvSpPr>
+          <p:cNvPr id="5" name="TextBox 4"/>
+          <p:cNvSpPr txBox="1"/>
+          <p:nvPr/>
+        </p:nvSpPr>
+        <p:spPr>
+          <a:xfrm>
+            <a:off x="548640" y="5989320"/>
+            <a:ext cx="11094415" cy="548640"/>
+          </a:xfrm>
+          <a:prstGeom prst="rect">
+            <a:avLst/>
+          </a:prstGeom>
+          <a:noFill/>
+        </p:spPr>
+        <p:txBody>
+          <a:bodyPr wrap="square" lIns="0" rIns="0" tIns="0" bIns="0">
+            <a:spAutoFit/>
+          </a:bodyPr>
+          <a:lstStyle/>
+          <a:p>
+            <a:pPr algn="l">
+              <a:spcAft>
+                <a:spcPts val="600"/>
+              </a:spcAft>
+            </a:pPr>
+            <a:r>
+              <a:rPr sz="1400" b="0" i="0">
+                <a:solidFill>
+                  <a:srgbClr val="5F6B73"/>
+                </a:solidFill>
+                <a:latin typeface="Calibri"/>
+              </a:rPr>
+              <a:t>The gap is present without the shift (Tier 0), so it is a controller-quality gap, not a robustness gap — the same shape W1 found for Phase 2c.</a:t>
+            </a:r>
+          </a:p>
+        </p:txBody>
+      </p:sp>
+    </p:spTree>
+  </p:cSld>
+  <p:clrMapOvr>
+    <a:masterClrMapping/>
+  </p:clrMapOvr>
+</p:sld>
+</file>
+
+<file path=ppt/slides/slide19.xml><?xml version="1.0" encoding="utf-8"?>
+<p:sld xmlns:a="http://schemas.openxmlformats.org/drawingml/2006/main" xmlns:p="http://schemas.openxmlformats.org/presentationml/2006/main" xmlns:r="http://schemas.openxmlformats.org/officeDocument/2006/relationships">
+  <p:cSld>
+    <p:bg>
+      <p:bgPr>
+        <a:solidFill>
+          <a:srgbClr val="FFFFFF"/>
+        </a:solidFill>
+        <a:effectLst/>
+      </p:bgPr>
+    </p:bg>
+    <p:spTree>
+      <p:nvGrpSpPr>
+        <p:cNvPr id="1" name=""/>
+        <p:cNvGrpSpPr/>
+        <p:nvPr/>
+      </p:nvGrpSpPr>
+      <p:grpSpPr/>
+      <p:sp>
+        <p:nvSpPr>
+          <p:cNvPr id="2" name="TextBox 1"/>
+          <p:cNvSpPr txBox="1"/>
+          <p:nvPr/>
+        </p:nvSpPr>
+        <p:spPr>
+          <a:xfrm>
+            <a:off x="548640" y="411480"/>
+            <a:ext cx="11094415" cy="731520"/>
+          </a:xfrm>
+          <a:prstGeom prst="rect">
+            <a:avLst/>
+          </a:prstGeom>
+          <a:noFill/>
+        </p:spPr>
+        <p:txBody>
+          <a:bodyPr wrap="square" lIns="0" rIns="0" tIns="0" bIns="0">
+            <a:spAutoFit/>
+          </a:bodyPr>
+          <a:lstStyle/>
+          <a:p>
+            <a:pPr algn="l">
+              <a:spcAft>
+                <a:spcPts val="600"/>
+              </a:spcAft>
+            </a:pPr>
+            <a:r>
+              <a:rPr sz="3400" b="1" i="0">
+                <a:solidFill>
+                  <a:srgbClr val="1F3B4D"/>
+                </a:solidFill>
+                <a:latin typeface="Cambria"/>
+              </a:rPr>
+              <a:t>Four ways this evaluation lied — each now a gate</a:t>
+            </a:r>
+          </a:p>
+        </p:txBody>
+      </p:sp>
+      <p:sp>
+        <p:nvSpPr>
+          <p:cNvPr id="3" name="Rounded Rectangle 2"/>
+          <p:cNvSpPr/>
+          <p:nvPr/>
+        </p:nvSpPr>
+        <p:spPr>
+          <a:xfrm>
+            <a:off x="548640" y="1417320"/>
+            <a:ext cx="5349240" cy="2286000"/>
+          </a:xfrm>
+          <a:prstGeom prst="roundRect">
+            <a:avLst>
+              <a:gd name="adj" fmla="val 6000"/>
+            </a:avLst>
+          </a:prstGeom>
+          <a:solidFill>
+            <a:srgbClr val="EEF3F5"/>
+          </a:solidFill>
+          <a:ln>
+            <a:noFill/>
+          </a:ln>
+          <a:effectLst/>
+        </p:spPr>
+        <p:style>
+          <a:lnRef idx="1">
+            <a:schemeClr val="accent1"/>
+          </a:lnRef>
+          <a:fillRef idx="3">
+            <a:schemeClr val="accent1"/>
+          </a:fillRef>
+          <a:effectRef idx="2">
+            <a:schemeClr val="accent1"/>
+          </a:effectRef>
+          <a:fontRef idx="minor">
+            <a:schemeClr val="lt1"/>
+          </a:fontRef>
+        </p:style>
+        <p:txBody>
+          <a:bodyPr rtlCol="0" anchor="ctr"/>
+          <a:lstStyle/>
+          <a:p>
+            <a:pPr algn="ctr"/>
           </a:p>
         </p:txBody>
       </p:sp>
@@ -10550,8 +10925,8 @@
         </p:nvSpPr>
         <p:spPr>
           <a:xfrm>
-            <a:off x="548640" y="1920240"/>
-            <a:ext cx="685800" cy="685800"/>
+            <a:off x="822959" y="1691640"/>
+            <a:ext cx="457200" cy="457200"/>
           </a:xfrm>
           <a:prstGeom prst="ellipse">
             <a:avLst/>
@@ -10584,13 +10959,13 @@
           <a:p>
             <a:pPr algn="ctr"/>
             <a:r>
-              <a:rPr sz="1300" b="1">
+              <a:rPr sz="1600" b="1">
                 <a:solidFill>
                   <a:srgbClr val="FFFFFF"/>
                 </a:solidFill>
                 <a:latin typeface="Calibri"/>
               </a:rPr>
-              <a:t>Rule</a:t>
+              <a:t>1</a:t>
             </a:r>
           </a:p>
         </p:txBody>
@@ -10603,8 +10978,8 @@
         </p:nvSpPr>
         <p:spPr>
           <a:xfrm>
-            <a:off x="1508760" y="2029968"/>
-            <a:ext cx="9875520" cy="822960"/>
+            <a:off x="1463040" y="1709928"/>
+            <a:ext cx="4206240" cy="457200"/>
           </a:xfrm>
           <a:prstGeom prst="rect">
             <a:avLst/>
@@ -10623,33 +10998,122 @@
               </a:spcAft>
             </a:pPr>
             <a:r>
-              <a:rPr sz="1700" b="0" i="0">
-                <a:solidFill>
-                  <a:srgbClr val="FFFFFF"/>
-                </a:solidFill>
-                <a:latin typeface="Calibri"/>
-              </a:rPr>
-              <a:t>decide per-cell vs per-arm validity before any new registration</a:t>
-            </a:r>
-          </a:p>
-        </p:txBody>
-      </p:sp>
-      <p:sp>
-        <p:nvSpPr>
-          <p:cNvPr id="6" name="Oval 5"/>
+              <a:rPr sz="1800" b="1" i="0">
+                <a:solidFill>
+                  <a:srgbClr val="1F3B4D"/>
+                </a:solidFill>
+                <a:latin typeface="Cambria"/>
+              </a:rPr>
+              <a:t>An open-loop schedule</a:t>
+            </a:r>
+          </a:p>
+        </p:txBody>
+      </p:sp>
+      <p:sp>
+        <p:nvSpPr>
+          <p:cNvPr id="6" name="TextBox 5"/>
+          <p:cNvSpPr txBox="1"/>
+          <p:nvPr/>
+        </p:nvSpPr>
+        <p:spPr>
+          <a:xfrm>
+            <a:off x="822959" y="2286000"/>
+            <a:ext cx="4800600" cy="868680"/>
+          </a:xfrm>
+          <a:prstGeom prst="rect">
+            <a:avLst/>
+          </a:prstGeom>
+          <a:noFill/>
+        </p:spPr>
+        <p:txBody>
+          <a:bodyPr wrap="square" lIns="0" rIns="0" tIns="0" bIns="0">
+            <a:spAutoFit/>
+          </a:bodyPr>
+          <a:lstStyle/>
+          <a:p>
+            <a:pPr algn="l">
+              <a:spcAft>
+                <a:spcPts val="600"/>
+              </a:spcAft>
+            </a:pPr>
+            <a:r>
+              <a:rPr sz="1300" b="0" i="0">
+                <a:solidFill>
+                  <a:srgbClr val="5F6B73"/>
+                </a:solidFill>
+                <a:latin typeface="Calibri"/>
+              </a:rPr>
+              <a:t>The ODE-RNN gave all 200 patients one identical dosing history and still reported a respectable TTP (L312).</a:t>
+            </a:r>
+          </a:p>
+        </p:txBody>
+      </p:sp>
+      <p:sp>
+        <p:nvSpPr>
+          <p:cNvPr id="7" name="TextBox 6"/>
+          <p:cNvSpPr txBox="1"/>
+          <p:nvPr/>
+        </p:nvSpPr>
+        <p:spPr>
+          <a:xfrm>
+            <a:off x="822959" y="3154680"/>
+            <a:ext cx="4800600" cy="411480"/>
+          </a:xfrm>
+          <a:prstGeom prst="rect">
+            <a:avLst/>
+          </a:prstGeom>
+          <a:noFill/>
+        </p:spPr>
+        <p:txBody>
+          <a:bodyPr wrap="square" lIns="0" rIns="0" tIns="0" bIns="0">
+            <a:spAutoFit/>
+          </a:bodyPr>
+          <a:lstStyle/>
+          <a:p>
+            <a:pPr algn="l">
+              <a:spcAft>
+                <a:spcPts val="600"/>
+              </a:spcAft>
+            </a:pPr>
+            <a:r>
+              <a:rPr sz="1300" b="1" i="0">
+                <a:solidFill>
+                  <a:srgbClr val="2A9D8F"/>
+                </a:solidFill>
+                <a:latin typeface="Calibri"/>
+              </a:rPr>
+              <a:t>Fix: </a:t>
+            </a:r>
+            <a:r>
+              <a:rPr sz="1300" b="0" i="0">
+                <a:solidFill>
+                  <a:srgbClr val="1F3B4D"/>
+                </a:solidFill>
+                <a:latin typeface="Calibri"/>
+              </a:rPr>
+              <a:t>closed-loop validity ≥ 0.10 per cell</a:t>
+            </a:r>
+          </a:p>
+        </p:txBody>
+      </p:sp>
+      <p:sp>
+        <p:nvSpPr>
+          <p:cNvPr id="8" name="Rounded Rectangle 7"/>
           <p:cNvSpPr/>
           <p:nvPr/>
         </p:nvSpPr>
         <p:spPr>
           <a:xfrm>
-            <a:off x="548640" y="2971800"/>
-            <a:ext cx="685800" cy="685800"/>
-          </a:xfrm>
-          <a:prstGeom prst="ellipse">
-            <a:avLst/>
+            <a:off x="6217920" y="1417320"/>
+            <a:ext cx="5349240" cy="2286000"/>
+          </a:xfrm>
+          <a:prstGeom prst="roundRect">
+            <a:avLst>
+              <a:gd name="adj" fmla="val 6000"/>
+            </a:avLst>
           </a:prstGeom>
           <a:solidFill>
-            <a:srgbClr val="2A9D8F"/>
+            <a:srgbClr val="EEF3F5"/>
           </a:solidFill>
           <a:ln>
             <a:noFill/>
@@ -10671,71 +11135,23 @@
           </a:fontRef>
         </p:style>
         <p:txBody>
-          <a:bodyPr rtlCol="0" anchor="ctr" lIns="0" rIns="0" tIns="0" bIns="0"/>
+          <a:bodyPr rtlCol="0" anchor="ctr"/>
           <a:lstStyle/>
           <a:p>
             <a:pPr algn="ctr"/>
-            <a:r>
-              <a:rPr sz="1300" b="1">
-                <a:solidFill>
-                  <a:srgbClr val="FFFFFF"/>
-                </a:solidFill>
-                <a:latin typeface="Calibri"/>
-              </a:rPr>
-              <a:t>W4</a:t>
-            </a:r>
-          </a:p>
-        </p:txBody>
-      </p:sp>
-      <p:sp>
-        <p:nvSpPr>
-          <p:cNvPr id="7" name="TextBox 6"/>
-          <p:cNvSpPr txBox="1"/>
-          <p:nvPr/>
-        </p:nvSpPr>
-        <p:spPr>
-          <a:xfrm>
-            <a:off x="1508760" y="3081528"/>
-            <a:ext cx="9875520" cy="822960"/>
-          </a:xfrm>
-          <a:prstGeom prst="rect">
-            <a:avLst/>
-          </a:prstGeom>
-          <a:noFill/>
-        </p:spPr>
-        <p:txBody>
-          <a:bodyPr wrap="square" lIns="0" rIns="0" tIns="0" bIns="0">
-            <a:spAutoFit/>
-          </a:bodyPr>
-          <a:lstStyle/>
-          <a:p>
-            <a:pPr algn="l">
-              <a:spcAft>
-                <a:spcPts val="600"/>
-              </a:spcAft>
-            </a:pPr>
-            <a:r>
-              <a:rPr sz="1700" b="0" i="0">
-                <a:solidFill>
-                  <a:srgbClr val="FFFFFF"/>
-                </a:solidFill>
-                <a:latin typeface="Calibri"/>
-              </a:rPr>
-              <a:t>irregular visits (20% / 50% dropped) — where continuous time has a mechanical reason to help; LSTM + Δt as the strong discrete baseline</a:t>
-            </a:r>
-          </a:p>
-        </p:txBody>
-      </p:sp>
-      <p:sp>
-        <p:nvSpPr>
-          <p:cNvPr id="8" name="Oval 7"/>
+          </a:p>
+        </p:txBody>
+      </p:sp>
+      <p:sp>
+        <p:nvSpPr>
+          <p:cNvPr id="9" name="Oval 8"/>
           <p:cNvSpPr/>
           <p:nvPr/>
         </p:nvSpPr>
         <p:spPr>
           <a:xfrm>
-            <a:off x="548640" y="4023360"/>
-            <a:ext cx="685800" cy="685800"/>
+            <a:off x="6492240" y="1691640"/>
+            <a:ext cx="457200" cy="457200"/>
           </a:xfrm>
           <a:prstGeom prst="ellipse">
             <a:avLst/>
@@ -10768,27 +11184,27 @@
           <a:p>
             <a:pPr algn="ctr"/>
             <a:r>
-              <a:rPr sz="1300" b="1">
+              <a:rPr sz="1600" b="1">
                 <a:solidFill>
                   <a:srgbClr val="FFFFFF"/>
                 </a:solidFill>
                 <a:latin typeface="Calibri"/>
               </a:rPr>
-              <a:t>W5</a:t>
-            </a:r>
-          </a:p>
-        </p:txBody>
-      </p:sp>
-      <p:sp>
-        <p:nvSpPr>
-          <p:cNvPr id="9" name="TextBox 8"/>
+              <a:t>2</a:t>
+            </a:r>
+          </a:p>
+        </p:txBody>
+      </p:sp>
+      <p:sp>
+        <p:nvSpPr>
+          <p:cNvPr id="10" name="TextBox 9"/>
           <p:cNvSpPr txBox="1"/>
           <p:nvPr/>
         </p:nvSpPr>
         <p:spPr>
           <a:xfrm>
-            <a:off x="1508760" y="4133088"/>
-            <a:ext cx="9875520" cy="822960"/>
+            <a:off x="7132320" y="1709928"/>
+            <a:ext cx="4206240" cy="457200"/>
           </a:xfrm>
           <a:prstGeom prst="rect">
             <a:avLst/>
@@ -10807,27 +11223,160 @@
               </a:spcAft>
             </a:pPr>
             <a:r>
-              <a:rPr sz="1700" b="0" i="0">
-                <a:solidFill>
-                  <a:srgbClr val="FFFFFF"/>
-                </a:solidFill>
-                <a:latin typeface="Calibri"/>
-              </a:rPr>
-              <a:t>mechanism shift — only if Hahnfeldt's day-7 resolution limit is fixed</a:t>
-            </a:r>
-          </a:p>
-        </p:txBody>
-      </p:sp>
-      <p:sp>
-        <p:nvSpPr>
-          <p:cNvPr id="10" name="Oval 9"/>
+              <a:rPr sz="1800" b="1" i="0">
+                <a:solidFill>
+                  <a:srgbClr val="1F3B4D"/>
+                </a:solidFill>
+                <a:latin typeface="Cambria"/>
+              </a:rPr>
+              <a:t>The progressor-only median</a:t>
+            </a:r>
+          </a:p>
+        </p:txBody>
+      </p:sp>
+      <p:sp>
+        <p:nvSpPr>
+          <p:cNvPr id="11" name="TextBox 10"/>
+          <p:cNvSpPr txBox="1"/>
+          <p:nvPr/>
+        </p:nvSpPr>
+        <p:spPr>
+          <a:xfrm>
+            <a:off x="6492240" y="2286000"/>
+            <a:ext cx="4800600" cy="868680"/>
+          </a:xfrm>
+          <a:prstGeom prst="rect">
+            <a:avLst/>
+          </a:prstGeom>
+          <a:noFill/>
+        </p:spPr>
+        <p:txBody>
+          <a:bodyPr wrap="square" lIns="0" rIns="0" tIns="0" bIns="0">
+            <a:spAutoFit/>
+          </a:bodyPr>
+          <a:lstStyle/>
+          <a:p>
+            <a:pPr algn="l">
+              <a:spcAft>
+                <a:spcPts val="600"/>
+              </a:spcAft>
+            </a:pPr>
+            <a:r>
+              <a:rPr sz="1300" b="0" i="0">
+                <a:solidFill>
+                  <a:srgbClr val="5F6B73"/>
+                </a:solidFill>
+                <a:latin typeface="Calibri"/>
+              </a:rPr>
+              <a:t>Averaging only patients who progress rewards letting more of them progress; it inverted the paired result 3 times.</a:t>
+            </a:r>
+          </a:p>
+        </p:txBody>
+      </p:sp>
+      <p:sp>
+        <p:nvSpPr>
+          <p:cNvPr id="12" name="TextBox 11"/>
+          <p:cNvSpPr txBox="1"/>
+          <p:nvPr/>
+        </p:nvSpPr>
+        <p:spPr>
+          <a:xfrm>
+            <a:off x="6492240" y="3154680"/>
+            <a:ext cx="4800600" cy="411480"/>
+          </a:xfrm>
+          <a:prstGeom prst="rect">
+            <a:avLst/>
+          </a:prstGeom>
+          <a:noFill/>
+        </p:spPr>
+        <p:txBody>
+          <a:bodyPr wrap="square" lIns="0" rIns="0" tIns="0" bIns="0">
+            <a:spAutoFit/>
+          </a:bodyPr>
+          <a:lstStyle/>
+          <a:p>
+            <a:pPr algn="l">
+              <a:spcAft>
+                <a:spcPts val="600"/>
+              </a:spcAft>
+            </a:pPr>
+            <a:r>
+              <a:rPr sz="1300" b="1" i="0">
+                <a:solidFill>
+                  <a:srgbClr val="2A9D8F"/>
+                </a:solidFill>
+                <a:latin typeface="Calibri"/>
+              </a:rPr>
+              <a:t>Fix: </a:t>
+            </a:r>
+            <a:r>
+              <a:rPr sz="1300" b="0" i="0">
+                <a:solidFill>
+                  <a:srgbClr val="1F3B4D"/>
+                </a:solidFill>
+                <a:latin typeface="Calibri"/>
+              </a:rPr>
+              <a:t>min(TTP, horizon) over all patients</a:t>
+            </a:r>
+          </a:p>
+        </p:txBody>
+      </p:sp>
+      <p:sp>
+        <p:nvSpPr>
+          <p:cNvPr id="13" name="Rounded Rectangle 12"/>
           <p:cNvSpPr/>
           <p:nvPr/>
         </p:nvSpPr>
         <p:spPr>
           <a:xfrm>
-            <a:off x="548640" y="5074920"/>
-            <a:ext cx="685800" cy="685800"/>
+            <a:off x="548640" y="3931920"/>
+            <a:ext cx="5349240" cy="2286000"/>
+          </a:xfrm>
+          <a:prstGeom prst="roundRect">
+            <a:avLst>
+              <a:gd name="adj" fmla="val 6000"/>
+            </a:avLst>
+          </a:prstGeom>
+          <a:solidFill>
+            <a:srgbClr val="EEF3F5"/>
+          </a:solidFill>
+          <a:ln>
+            <a:noFill/>
+          </a:ln>
+          <a:effectLst/>
+        </p:spPr>
+        <p:style>
+          <a:lnRef idx="1">
+            <a:schemeClr val="accent1"/>
+          </a:lnRef>
+          <a:fillRef idx="3">
+            <a:schemeClr val="accent1"/>
+          </a:fillRef>
+          <a:effectRef idx="2">
+            <a:schemeClr val="accent1"/>
+          </a:effectRef>
+          <a:fontRef idx="minor">
+            <a:schemeClr val="lt1"/>
+          </a:fontRef>
+        </p:style>
+        <p:txBody>
+          <a:bodyPr rtlCol="0" anchor="ctr"/>
+          <a:lstStyle/>
+          <a:p>
+            <a:pPr algn="ctr"/>
+          </a:p>
+        </p:txBody>
+      </p:sp>
+      <p:sp>
+        <p:nvSpPr>
+          <p:cNvPr id="14" name="Oval 13"/>
+          <p:cNvSpPr/>
+          <p:nvPr/>
+        </p:nvSpPr>
+        <p:spPr>
+          <a:xfrm>
+            <a:off x="822959" y="4206240"/>
+            <a:ext cx="457200" cy="457200"/>
           </a:xfrm>
           <a:prstGeom prst="ellipse">
             <a:avLst/>
@@ -10860,27 +11409,27 @@
           <a:p>
             <a:pPr algn="ctr"/>
             <a:r>
-              <a:rPr sz="1300" b="1">
+              <a:rPr sz="1600" b="1">
                 <a:solidFill>
                   <a:srgbClr val="FFFFFF"/>
                 </a:solidFill>
                 <a:latin typeface="Calibri"/>
               </a:rPr>
-              <a:t>W6</a:t>
-            </a:r>
-          </a:p>
-        </p:txBody>
-      </p:sp>
-      <p:sp>
-        <p:nvSpPr>
-          <p:cNvPr id="11" name="TextBox 10"/>
+              <a:t>3</a:t>
+            </a:r>
+          </a:p>
+        </p:txBody>
+      </p:sp>
+      <p:sp>
+        <p:nvSpPr>
+          <p:cNvPr id="15" name="TextBox 14"/>
           <p:cNvSpPr txBox="1"/>
           <p:nvPr/>
         </p:nvSpPr>
         <p:spPr>
           <a:xfrm>
-            <a:off x="1508760" y="5184648"/>
-            <a:ext cx="9875520" cy="822960"/>
+            <a:off x="1463040" y="4224528"/>
+            <a:ext cx="4206240" cy="457200"/>
           </a:xfrm>
           <a:prstGeom prst="rect">
             <a:avLst/>
@@ -10899,13 +11448,325 @@
               </a:spcAft>
             </a:pPr>
             <a:r>
-              <a:rPr sz="1700" b="0" i="0">
+              <a:rPr sz="1800" b="1" i="0">
+                <a:solidFill>
+                  <a:srgbClr val="1F3B4D"/>
+                </a:solidFill>
+                <a:latin typeface="Cambria"/>
+              </a:rPr>
+              <a:t>A mis-built shifted cohort</a:t>
+            </a:r>
+          </a:p>
+        </p:txBody>
+      </p:sp>
+      <p:sp>
+        <p:nvSpPr>
+          <p:cNvPr id="16" name="TextBox 15"/>
+          <p:cNvSpPr txBox="1"/>
+          <p:nvPr/>
+        </p:nvSpPr>
+        <p:spPr>
+          <a:xfrm>
+            <a:off x="822959" y="4800600"/>
+            <a:ext cx="4800600" cy="868680"/>
+          </a:xfrm>
+          <a:prstGeom prst="rect">
+            <a:avLst/>
+          </a:prstGeom>
+          <a:noFill/>
+        </p:spPr>
+        <p:txBody>
+          <a:bodyPr wrap="square" lIns="0" rIns="0" tIns="0" bIns="0">
+            <a:spAutoFit/>
+          </a:bodyPr>
+          <a:lstStyle/>
+          <a:p>
+            <a:pPr algn="l">
+              <a:spcAft>
+                <a:spcPts val="600"/>
+              </a:spcAft>
+            </a:pPr>
+            <a:r>
+              <a:rPr sz="1300" b="0" i="0">
+                <a:solidFill>
+                  <a:srgbClr val="5F6B73"/>
+                </a:solidFill>
+                <a:latin typeface="Calibri"/>
+              </a:rPr>
+              <a:t>Scaling K after building y0 put half the test cohort above capacity; NaN blow-ups scored as 'never progressed' (L242).</a:t>
+            </a:r>
+          </a:p>
+        </p:txBody>
+      </p:sp>
+      <p:sp>
+        <p:nvSpPr>
+          <p:cNvPr id="17" name="TextBox 16"/>
+          <p:cNvSpPr txBox="1"/>
+          <p:nvPr/>
+        </p:nvSpPr>
+        <p:spPr>
+          <a:xfrm>
+            <a:off x="822959" y="5669279"/>
+            <a:ext cx="4800600" cy="411480"/>
+          </a:xfrm>
+          <a:prstGeom prst="rect">
+            <a:avLst/>
+          </a:prstGeom>
+          <a:noFill/>
+        </p:spPr>
+        <p:txBody>
+          <a:bodyPr wrap="square" lIns="0" rIns="0" tIns="0" bIns="0">
+            <a:spAutoFit/>
+          </a:bodyPr>
+          <a:lstStyle/>
+          <a:p>
+            <a:pPr algn="l">
+              <a:spcAft>
+                <a:spcPts val="600"/>
+              </a:spcAft>
+            </a:pPr>
+            <a:r>
+              <a:rPr sz="1300" b="1" i="0">
+                <a:solidFill>
+                  <a:srgbClr val="2A9D8F"/>
+                </a:solidFill>
+                <a:latin typeface="Calibri"/>
+              </a:rPr>
+              <a:t>Fix: </a:t>
+            </a:r>
+            <a:r>
+              <a:rPr sz="1300" b="0" i="0">
+                <a:solidFill>
+                  <a:srgbClr val="1F3B4D"/>
+                </a:solidFill>
+                <a:latin typeface="Calibri"/>
+              </a:rPr>
+              <a:t>rebuild y0 from shifted θ; refuse NaN</a:t>
+            </a:r>
+          </a:p>
+        </p:txBody>
+      </p:sp>
+      <p:sp>
+        <p:nvSpPr>
+          <p:cNvPr id="18" name="Rounded Rectangle 17"/>
+          <p:cNvSpPr/>
+          <p:nvPr/>
+        </p:nvSpPr>
+        <p:spPr>
+          <a:xfrm>
+            <a:off x="6217920" y="3931920"/>
+            <a:ext cx="5349240" cy="2286000"/>
+          </a:xfrm>
+          <a:prstGeom prst="roundRect">
+            <a:avLst>
+              <a:gd name="adj" fmla="val 6000"/>
+            </a:avLst>
+          </a:prstGeom>
+          <a:solidFill>
+            <a:srgbClr val="EEF3F5"/>
+          </a:solidFill>
+          <a:ln>
+            <a:noFill/>
+          </a:ln>
+          <a:effectLst/>
+        </p:spPr>
+        <p:style>
+          <a:lnRef idx="1">
+            <a:schemeClr val="accent1"/>
+          </a:lnRef>
+          <a:fillRef idx="3">
+            <a:schemeClr val="accent1"/>
+          </a:fillRef>
+          <a:effectRef idx="2">
+            <a:schemeClr val="accent1"/>
+          </a:effectRef>
+          <a:fontRef idx="minor">
+            <a:schemeClr val="lt1"/>
+          </a:fontRef>
+        </p:style>
+        <p:txBody>
+          <a:bodyPr rtlCol="0" anchor="ctr"/>
+          <a:lstStyle/>
+          <a:p>
+            <a:pPr algn="ctr"/>
+          </a:p>
+        </p:txBody>
+      </p:sp>
+      <p:sp>
+        <p:nvSpPr>
+          <p:cNvPr id="19" name="Oval 18"/>
+          <p:cNvSpPr/>
+          <p:nvPr/>
+        </p:nvSpPr>
+        <p:spPr>
+          <a:xfrm>
+            <a:off x="6492240" y="4206240"/>
+            <a:ext cx="457200" cy="457200"/>
+          </a:xfrm>
+          <a:prstGeom prst="ellipse">
+            <a:avLst/>
+          </a:prstGeom>
+          <a:solidFill>
+            <a:srgbClr val="D1495B"/>
+          </a:solidFill>
+          <a:ln>
+            <a:noFill/>
+          </a:ln>
+          <a:effectLst/>
+        </p:spPr>
+        <p:style>
+          <a:lnRef idx="1">
+            <a:schemeClr val="accent1"/>
+          </a:lnRef>
+          <a:fillRef idx="3">
+            <a:schemeClr val="accent1"/>
+          </a:fillRef>
+          <a:effectRef idx="2">
+            <a:schemeClr val="accent1"/>
+          </a:effectRef>
+          <a:fontRef idx="minor">
+            <a:schemeClr val="lt1"/>
+          </a:fontRef>
+        </p:style>
+        <p:txBody>
+          <a:bodyPr rtlCol="0" anchor="ctr" lIns="0" rIns="0" tIns="0" bIns="0"/>
+          <a:lstStyle/>
+          <a:p>
+            <a:pPr algn="ctr"/>
+            <a:r>
+              <a:rPr sz="1600" b="1">
                 <a:solidFill>
                   <a:srgbClr val="FFFFFF"/>
                 </a:solidFill>
                 <a:latin typeface="Calibri"/>
               </a:rPr>
-              <a:t>write-up: validity across trainers, frontiers, the learned threshold rule, every run in one table</a:t>
+              <a:t>4</a:t>
+            </a:r>
+          </a:p>
+        </p:txBody>
+      </p:sp>
+      <p:sp>
+        <p:nvSpPr>
+          <p:cNvPr id="20" name="TextBox 19"/>
+          <p:cNvSpPr txBox="1"/>
+          <p:nvPr/>
+        </p:nvSpPr>
+        <p:spPr>
+          <a:xfrm>
+            <a:off x="7132320" y="4224528"/>
+            <a:ext cx="4206240" cy="457200"/>
+          </a:xfrm>
+          <a:prstGeom prst="rect">
+            <a:avLst/>
+          </a:prstGeom>
+          <a:noFill/>
+        </p:spPr>
+        <p:txBody>
+          <a:bodyPr wrap="square" lIns="0" rIns="0" tIns="0" bIns="0">
+            <a:spAutoFit/>
+          </a:bodyPr>
+          <a:lstStyle/>
+          <a:p>
+            <a:pPr algn="l">
+              <a:spcAft>
+                <a:spcPts val="600"/>
+              </a:spcAft>
+            </a:pPr>
+            <a:r>
+              <a:rPr sz="1800" b="1" i="0">
+                <a:solidFill>
+                  <a:srgbClr val="1F3B4D"/>
+                </a:solidFill>
+                <a:latin typeface="Cambria"/>
+              </a:rPr>
+              <a:t>A metric at its ceiling</a:t>
+            </a:r>
+          </a:p>
+        </p:txBody>
+      </p:sp>
+      <p:sp>
+        <p:nvSpPr>
+          <p:cNvPr id="21" name="TextBox 20"/>
+          <p:cNvSpPr txBox="1"/>
+          <p:nvPr/>
+        </p:nvSpPr>
+        <p:spPr>
+          <a:xfrm>
+            <a:off x="6492240" y="4800600"/>
+            <a:ext cx="4800600" cy="868680"/>
+          </a:xfrm>
+          <a:prstGeom prst="rect">
+            <a:avLst/>
+          </a:prstGeom>
+          <a:noFill/>
+        </p:spPr>
+        <p:txBody>
+          <a:bodyPr wrap="square" lIns="0" rIns="0" tIns="0" bIns="0">
+            <a:spAutoFit/>
+          </a:bodyPr>
+          <a:lstStyle/>
+          <a:p>
+            <a:pPr algn="l">
+              <a:spcAft>
+                <a:spcPts val="600"/>
+              </a:spcAft>
+            </a:pPr>
+            <a:r>
+              <a:rPr sz="1300" b="0" i="0">
+                <a:solidFill>
+                  <a:srgbClr val="5F6B73"/>
+                </a:solidFill>
+                <a:latin typeface="Calibri"/>
+              </a:rPr>
+              <a:t>Once &gt; 50% never progress, a capped median is flat at the horizon and ranks nothing (L496).</a:t>
+            </a:r>
+          </a:p>
+        </p:txBody>
+      </p:sp>
+      <p:sp>
+        <p:nvSpPr>
+          <p:cNvPr id="22" name="TextBox 21"/>
+          <p:cNvSpPr txBox="1"/>
+          <p:nvPr/>
+        </p:nvSpPr>
+        <p:spPr>
+          <a:xfrm>
+            <a:off x="6492240" y="5669279"/>
+            <a:ext cx="4800600" cy="411480"/>
+          </a:xfrm>
+          <a:prstGeom prst="rect">
+            <a:avLst/>
+          </a:prstGeom>
+          <a:noFill/>
+        </p:spPr>
+        <p:txBody>
+          <a:bodyPr wrap="square" lIns="0" rIns="0" tIns="0" bIns="0">
+            <a:spAutoFit/>
+          </a:bodyPr>
+          <a:lstStyle/>
+          <a:p>
+            <a:pPr algn="l">
+              <a:spcAft>
+                <a:spcPts val="600"/>
+              </a:spcAft>
+            </a:pPr>
+            <a:r>
+              <a:rPr sz="1300" b="1" i="0">
+                <a:solidFill>
+                  <a:srgbClr val="2A9D8F"/>
+                </a:solidFill>
+                <a:latin typeface="Calibri"/>
+              </a:rPr>
+              <a:t>Fix: </a:t>
+            </a:r>
+            <a:r>
+              <a:rPr sz="1300" b="0" i="0">
+                <a:solidFill>
+                  <a:srgbClr val="1F3B4D"/>
+                </a:solidFill>
+                <a:latin typeface="Calibri"/>
+              </a:rPr>
+              <a:t>restricted-mean TTP (W3b)</a:t>
             </a:r>
           </a:p>
         </p:txBody>
@@ -12247,6 +13108,478 @@
                 <a:latin typeface="Calibri"/>
               </a:rPr>
               <a:t>time to progression (TTP: +20% over running nadir, 28-day confirmation) and cumulative drug exposure. Paired by patient, ≥ 3 seeds.</a:t>
+            </a:r>
+          </a:p>
+        </p:txBody>
+      </p:sp>
+    </p:spTree>
+  </p:cSld>
+  <p:clrMapOvr>
+    <a:masterClrMapping/>
+  </p:clrMapOvr>
+</p:sld>
+</file>
+
+<file path=ppt/slides/slide20.xml><?xml version="1.0" encoding="utf-8"?>
+<p:sld xmlns:a="http://schemas.openxmlformats.org/drawingml/2006/main" xmlns:p="http://schemas.openxmlformats.org/presentationml/2006/main" xmlns:r="http://schemas.openxmlformats.org/officeDocument/2006/relationships">
+  <p:cSld>
+    <p:bg>
+      <p:bgPr>
+        <a:solidFill>
+          <a:srgbClr val="1F3B4D"/>
+        </a:solidFill>
+        <a:effectLst/>
+      </p:bgPr>
+    </p:bg>
+    <p:spTree>
+      <p:nvGrpSpPr>
+        <p:cNvPr id="1" name=""/>
+        <p:cNvGrpSpPr/>
+        <p:nvPr/>
+      </p:nvGrpSpPr>
+      <p:grpSpPr/>
+      <p:sp>
+        <p:nvSpPr>
+          <p:cNvPr id="2" name="TextBox 1"/>
+          <p:cNvSpPr txBox="1"/>
+          <p:nvPr/>
+        </p:nvSpPr>
+        <p:spPr>
+          <a:xfrm>
+            <a:off x="548640" y="411480"/>
+            <a:ext cx="11094415" cy="731520"/>
+          </a:xfrm>
+          <a:prstGeom prst="rect">
+            <a:avLst/>
+          </a:prstGeom>
+          <a:noFill/>
+        </p:spPr>
+        <p:txBody>
+          <a:bodyPr wrap="square" lIns="0" rIns="0" tIns="0" bIns="0">
+            <a:spAutoFit/>
+          </a:bodyPr>
+          <a:lstStyle/>
+          <a:p>
+            <a:pPr algn="l">
+              <a:spcAft>
+                <a:spcPts val="600"/>
+              </a:spcAft>
+            </a:pPr>
+            <a:r>
+              <a:rPr sz="3400" b="1" i="0">
+                <a:solidFill>
+                  <a:srgbClr val="FFFFFF"/>
+                </a:solidFill>
+                <a:latin typeface="Cambria"/>
+              </a:rPr>
+              <a:t>Next</a:t>
+            </a:r>
+          </a:p>
+        </p:txBody>
+      </p:sp>
+      <p:sp>
+        <p:nvSpPr>
+          <p:cNvPr id="3" name="TextBox 2"/>
+          <p:cNvSpPr txBox="1"/>
+          <p:nvPr/>
+        </p:nvSpPr>
+        <p:spPr>
+          <a:xfrm>
+            <a:off x="548640" y="1097280"/>
+            <a:ext cx="11094415" cy="457200"/>
+          </a:xfrm>
+          <a:prstGeom prst="rect">
+            <a:avLst/>
+          </a:prstGeom>
+          <a:noFill/>
+        </p:spPr>
+        <p:txBody>
+          <a:bodyPr wrap="square" lIns="0" rIns="0" tIns="0" bIns="0">
+            <a:spAutoFit/>
+          </a:bodyPr>
+          <a:lstStyle/>
+          <a:p>
+            <a:pPr algn="l">
+              <a:spcAft>
+                <a:spcPts val="600"/>
+              </a:spcAft>
+            </a:pPr>
+            <a:r>
+              <a:rPr sz="1600" b="0" i="1">
+                <a:solidFill>
+                  <a:srgbClr val="EEF3F5"/>
+                </a:solidFill>
+                <a:latin typeface="Calibri"/>
+              </a:rPr>
+              <a:t>Target: ICLR 2027 workshop — a clean negative is still the paper</a:t>
+            </a:r>
+          </a:p>
+        </p:txBody>
+      </p:sp>
+      <p:sp>
+        <p:nvSpPr>
+          <p:cNvPr id="4" name="Oval 3"/>
+          <p:cNvSpPr/>
+          <p:nvPr/>
+        </p:nvSpPr>
+        <p:spPr>
+          <a:xfrm>
+            <a:off x="548640" y="1920240"/>
+            <a:ext cx="685800" cy="685800"/>
+          </a:xfrm>
+          <a:prstGeom prst="ellipse">
+            <a:avLst/>
+          </a:prstGeom>
+          <a:solidFill>
+            <a:srgbClr val="D1495B"/>
+          </a:solidFill>
+          <a:ln>
+            <a:noFill/>
+          </a:ln>
+          <a:effectLst/>
+        </p:spPr>
+        <p:style>
+          <a:lnRef idx="1">
+            <a:schemeClr val="accent1"/>
+          </a:lnRef>
+          <a:fillRef idx="3">
+            <a:schemeClr val="accent1"/>
+          </a:fillRef>
+          <a:effectRef idx="2">
+            <a:schemeClr val="accent1"/>
+          </a:effectRef>
+          <a:fontRef idx="minor">
+            <a:schemeClr val="lt1"/>
+          </a:fontRef>
+        </p:style>
+        <p:txBody>
+          <a:bodyPr rtlCol="0" anchor="ctr" lIns="0" rIns="0" tIns="0" bIns="0"/>
+          <a:lstStyle/>
+          <a:p>
+            <a:pPr algn="ctr"/>
+            <a:r>
+              <a:rPr sz="1300" b="1">
+                <a:solidFill>
+                  <a:srgbClr val="FFFFFF"/>
+                </a:solidFill>
+                <a:latin typeface="Calibri"/>
+              </a:rPr>
+              <a:t>Law</a:t>
+            </a:r>
+          </a:p>
+        </p:txBody>
+      </p:sp>
+      <p:sp>
+        <p:nvSpPr>
+          <p:cNvPr id="5" name="TextBox 4"/>
+          <p:cNvSpPr txBox="1"/>
+          <p:nvPr/>
+        </p:nvSpPr>
+        <p:spPr>
+          <a:xfrm>
+            <a:off x="1508760" y="2029968"/>
+            <a:ext cx="9875520" cy="822960"/>
+          </a:xfrm>
+          <a:prstGeom prst="rect">
+            <a:avLst/>
+          </a:prstGeom>
+          <a:noFill/>
+        </p:spPr>
+        <p:txBody>
+          <a:bodyPr wrap="square" lIns="0" rIns="0" tIns="0" bIns="0">
+            <a:spAutoFit/>
+          </a:bodyPr>
+          <a:lstStyle/>
+          <a:p>
+            <a:pPr algn="l">
+              <a:spcAft>
+                <a:spcPts val="600"/>
+              </a:spcAft>
+            </a:pPr>
+            <a:r>
+              <a:rPr sz="1700" b="0" i="0">
+                <a:solidFill>
+                  <a:srgbClr val="FFFFFF"/>
+                </a:solidFill>
+                <a:latin typeface="Calibri"/>
+              </a:rPr>
+              <a:t>promote 'no continuous-time edge on Tiers 0/1' — two valid closures (vs MLP, vs LSTM)</a:t>
+            </a:r>
+          </a:p>
+        </p:txBody>
+      </p:sp>
+      <p:sp>
+        <p:nvSpPr>
+          <p:cNvPr id="6" name="Oval 5"/>
+          <p:cNvSpPr/>
+          <p:nvPr/>
+        </p:nvSpPr>
+        <p:spPr>
+          <a:xfrm>
+            <a:off x="548640" y="2971800"/>
+            <a:ext cx="685800" cy="685800"/>
+          </a:xfrm>
+          <a:prstGeom prst="ellipse">
+            <a:avLst/>
+          </a:prstGeom>
+          <a:solidFill>
+            <a:srgbClr val="2A9D8F"/>
+          </a:solidFill>
+          <a:ln>
+            <a:noFill/>
+          </a:ln>
+          <a:effectLst/>
+        </p:spPr>
+        <p:style>
+          <a:lnRef idx="1">
+            <a:schemeClr val="accent1"/>
+          </a:lnRef>
+          <a:fillRef idx="3">
+            <a:schemeClr val="accent1"/>
+          </a:fillRef>
+          <a:effectRef idx="2">
+            <a:schemeClr val="accent1"/>
+          </a:effectRef>
+          <a:fontRef idx="minor">
+            <a:schemeClr val="lt1"/>
+          </a:fontRef>
+        </p:style>
+        <p:txBody>
+          <a:bodyPr rtlCol="0" anchor="ctr" lIns="0" rIns="0" tIns="0" bIns="0"/>
+          <a:lstStyle/>
+          <a:p>
+            <a:pPr algn="ctr"/>
+            <a:r>
+              <a:rPr sz="1300" b="1">
+                <a:solidFill>
+                  <a:srgbClr val="FFFFFF"/>
+                </a:solidFill>
+                <a:latin typeface="Calibri"/>
+              </a:rPr>
+              <a:t>W4</a:t>
+            </a:r>
+          </a:p>
+        </p:txBody>
+      </p:sp>
+      <p:sp>
+        <p:nvSpPr>
+          <p:cNvPr id="7" name="TextBox 6"/>
+          <p:cNvSpPr txBox="1"/>
+          <p:nvPr/>
+        </p:nvSpPr>
+        <p:spPr>
+          <a:xfrm>
+            <a:off x="1508760" y="3081528"/>
+            <a:ext cx="9875520" cy="822960"/>
+          </a:xfrm>
+          <a:prstGeom prst="rect">
+            <a:avLst/>
+          </a:prstGeom>
+          <a:noFill/>
+        </p:spPr>
+        <p:txBody>
+          <a:bodyPr wrap="square" lIns="0" rIns="0" tIns="0" bIns="0">
+            <a:spAutoFit/>
+          </a:bodyPr>
+          <a:lstStyle/>
+          <a:p>
+            <a:pPr algn="l">
+              <a:spcAft>
+                <a:spcPts val="600"/>
+              </a:spcAft>
+            </a:pPr>
+            <a:r>
+              <a:rPr sz="1700" b="0" i="0">
+                <a:solidFill>
+                  <a:srgbClr val="FFFFFF"/>
+                </a:solidFill>
+                <a:latin typeface="Calibri"/>
+              </a:rPr>
+              <a:t>irregular visits (20% / 50% dropped) — where continuous time has a mechanical reason to help; LSTM + Δt as the strong discrete baseline</a:t>
+            </a:r>
+          </a:p>
+        </p:txBody>
+      </p:sp>
+      <p:sp>
+        <p:nvSpPr>
+          <p:cNvPr id="8" name="Oval 7"/>
+          <p:cNvSpPr/>
+          <p:nvPr/>
+        </p:nvSpPr>
+        <p:spPr>
+          <a:xfrm>
+            <a:off x="548640" y="4023360"/>
+            <a:ext cx="685800" cy="685800"/>
+          </a:xfrm>
+          <a:prstGeom prst="ellipse">
+            <a:avLst/>
+          </a:prstGeom>
+          <a:solidFill>
+            <a:srgbClr val="D1495B"/>
+          </a:solidFill>
+          <a:ln>
+            <a:noFill/>
+          </a:ln>
+          <a:effectLst/>
+        </p:spPr>
+        <p:style>
+          <a:lnRef idx="1">
+            <a:schemeClr val="accent1"/>
+          </a:lnRef>
+          <a:fillRef idx="3">
+            <a:schemeClr val="accent1"/>
+          </a:fillRef>
+          <a:effectRef idx="2">
+            <a:schemeClr val="accent1"/>
+          </a:effectRef>
+          <a:fontRef idx="minor">
+            <a:schemeClr val="lt1"/>
+          </a:fontRef>
+        </p:style>
+        <p:txBody>
+          <a:bodyPr rtlCol="0" anchor="ctr" lIns="0" rIns="0" tIns="0" bIns="0"/>
+          <a:lstStyle/>
+          <a:p>
+            <a:pPr algn="ctr"/>
+            <a:r>
+              <a:rPr sz="1300" b="1">
+                <a:solidFill>
+                  <a:srgbClr val="FFFFFF"/>
+                </a:solidFill>
+                <a:latin typeface="Calibri"/>
+              </a:rPr>
+              <a:t>W5</a:t>
+            </a:r>
+          </a:p>
+        </p:txBody>
+      </p:sp>
+      <p:sp>
+        <p:nvSpPr>
+          <p:cNvPr id="9" name="TextBox 8"/>
+          <p:cNvSpPr txBox="1"/>
+          <p:nvPr/>
+        </p:nvSpPr>
+        <p:spPr>
+          <a:xfrm>
+            <a:off x="1508760" y="4133088"/>
+            <a:ext cx="9875520" cy="822960"/>
+          </a:xfrm>
+          <a:prstGeom prst="rect">
+            <a:avLst/>
+          </a:prstGeom>
+          <a:noFill/>
+        </p:spPr>
+        <p:txBody>
+          <a:bodyPr wrap="square" lIns="0" rIns="0" tIns="0" bIns="0">
+            <a:spAutoFit/>
+          </a:bodyPr>
+          <a:lstStyle/>
+          <a:p>
+            <a:pPr algn="l">
+              <a:spcAft>
+                <a:spcPts val="600"/>
+              </a:spcAft>
+            </a:pPr>
+            <a:r>
+              <a:rPr sz="1700" b="0" i="0">
+                <a:solidFill>
+                  <a:srgbClr val="FFFFFF"/>
+                </a:solidFill>
+                <a:latin typeface="Calibri"/>
+              </a:rPr>
+              <a:t>mechanism shift — only if Hahnfeldt's day-7 resolution limit is fixed</a:t>
+            </a:r>
+          </a:p>
+        </p:txBody>
+      </p:sp>
+      <p:sp>
+        <p:nvSpPr>
+          <p:cNvPr id="10" name="Oval 9"/>
+          <p:cNvSpPr/>
+          <p:nvPr/>
+        </p:nvSpPr>
+        <p:spPr>
+          <a:xfrm>
+            <a:off x="548640" y="5074920"/>
+            <a:ext cx="685800" cy="685800"/>
+          </a:xfrm>
+          <a:prstGeom prst="ellipse">
+            <a:avLst/>
+          </a:prstGeom>
+          <a:solidFill>
+            <a:srgbClr val="D1495B"/>
+          </a:solidFill>
+          <a:ln>
+            <a:noFill/>
+          </a:ln>
+          <a:effectLst/>
+        </p:spPr>
+        <p:style>
+          <a:lnRef idx="1">
+            <a:schemeClr val="accent1"/>
+          </a:lnRef>
+          <a:fillRef idx="3">
+            <a:schemeClr val="accent1"/>
+          </a:fillRef>
+          <a:effectRef idx="2">
+            <a:schemeClr val="accent1"/>
+          </a:effectRef>
+          <a:fontRef idx="minor">
+            <a:schemeClr val="lt1"/>
+          </a:fontRef>
+        </p:style>
+        <p:txBody>
+          <a:bodyPr rtlCol="0" anchor="ctr" lIns="0" rIns="0" tIns="0" bIns="0"/>
+          <a:lstStyle/>
+          <a:p>
+            <a:pPr algn="ctr"/>
+            <a:r>
+              <a:rPr sz="1300" b="1">
+                <a:solidFill>
+                  <a:srgbClr val="FFFFFF"/>
+                </a:solidFill>
+                <a:latin typeface="Calibri"/>
+              </a:rPr>
+              <a:t>W6</a:t>
+            </a:r>
+          </a:p>
+        </p:txBody>
+      </p:sp>
+      <p:sp>
+        <p:nvSpPr>
+          <p:cNvPr id="11" name="TextBox 10"/>
+          <p:cNvSpPr txBox="1"/>
+          <p:nvPr/>
+        </p:nvSpPr>
+        <p:spPr>
+          <a:xfrm>
+            <a:off x="1508760" y="5184648"/>
+            <a:ext cx="9875520" cy="822960"/>
+          </a:xfrm>
+          <a:prstGeom prst="rect">
+            <a:avLst/>
+          </a:prstGeom>
+          <a:noFill/>
+        </p:spPr>
+        <p:txBody>
+          <a:bodyPr wrap="square" lIns="0" rIns="0" tIns="0" bIns="0">
+            <a:spAutoFit/>
+          </a:bodyPr>
+          <a:lstStyle/>
+          <a:p>
+            <a:pPr algn="l">
+              <a:spcAft>
+                <a:spcPts val="600"/>
+              </a:spcAft>
+            </a:pPr>
+            <a:r>
+              <a:rPr sz="1700" b="0" i="0">
+                <a:solidFill>
+                  <a:srgbClr val="FFFFFF"/>
+                </a:solidFill>
+                <a:latin typeface="Calibri"/>
+              </a:rPr>
+              <a:t>write-up: validity across trainers, frontiers, the learned threshold rule, every run in one table</a:t>
             </a:r>
           </a:p>
         </p:txBody>

</xml_diff>